<commit_message>
Update FDS presentation designs
</commit_message>
<xml_diff>
--- a/FIT5147 FDS Slide template.pptx
+++ b/FIT5147 FDS Slide template.pptx
@@ -6681,111 +6681,14 @@
       </p:grpSp>
       <p:grpSp>
         <p:nvGrpSpPr>
-          <p:cNvPr id="9" name="Group 9"/>
+          <p:cNvPr id="12" name="Group 12"/>
           <p:cNvGrpSpPr/>
           <p:nvPr/>
         </p:nvGrpSpPr>
         <p:grpSpPr>
           <a:xfrm>
-            <a:off x="9695177" y="5307795"/>
-            <a:ext cx="8592823" cy="4979205"/>
-            <a:chOff x="0" y="0"/>
-            <a:chExt cx="2263130" cy="1311395"/>
-          </a:xfrm>
-        </p:grpSpPr>
-        <p:sp>
-          <p:nvSpPr>
-            <p:cNvPr id="10" name="Freeform 10"/>
-            <p:cNvSpPr/>
-            <p:nvPr/>
-          </p:nvSpPr>
-          <p:spPr>
-            <a:xfrm>
-              <a:off x="0" y="0"/>
-              <a:ext cx="2263130" cy="1311396"/>
-            </a:xfrm>
-            <a:custGeom>
-              <a:avLst/>
-              <a:gdLst/>
-              <a:ahLst/>
-              <a:cxnLst/>
-              <a:rect l="l" t="t" r="r" b="b"/>
-              <a:pathLst>
-                <a:path w="2263130" h="1311396">
-                  <a:moveTo>
-                    <a:pt x="0" y="0"/>
-                  </a:moveTo>
-                  <a:lnTo>
-                    <a:pt x="2263130" y="0"/>
-                  </a:lnTo>
-                  <a:lnTo>
-                    <a:pt x="2263130" y="1311396"/>
-                  </a:lnTo>
-                  <a:lnTo>
-                    <a:pt x="0" y="1311396"/>
-                  </a:lnTo>
-                  <a:close/>
-                </a:path>
-              </a:pathLst>
-            </a:custGeom>
-            <a:ln w="9525" cap="sq">
-              <a:solidFill>
-                <a:srgbClr val="000000"/>
-              </a:solidFill>
-              <a:prstDash val="solid"/>
-              <a:miter/>
-            </a:ln>
-          </p:spPr>
-          <p:txBody>
-            <a:bodyPr/>
-            <a:lstStyle/>
-            <a:p>
-              <a:endParaRPr lang="zh-HK" altLang="en-US"/>
-            </a:p>
-          </p:txBody>
-        </p:sp>
-        <p:sp>
-          <p:nvSpPr>
-            <p:cNvPr id="11" name="TextBox 11"/>
-            <p:cNvSpPr txBox="1"/>
-            <p:nvPr/>
-          </p:nvSpPr>
-          <p:spPr>
-            <a:xfrm>
-              <a:off x="0" y="-38100"/>
-              <a:ext cx="2263130" cy="1349495"/>
-            </a:xfrm>
-            <a:prstGeom prst="rect">
-              <a:avLst/>
-            </a:prstGeom>
-          </p:spPr>
-          <p:txBody>
-            <a:bodyPr lIns="50800" tIns="50800" rIns="50800" bIns="50800" rtlCol="0" anchor="ctr"/>
-            <a:lstStyle/>
-            <a:p>
-              <a:pPr algn="ctr">
-                <a:lnSpc>
-                  <a:spcPts val="2659"/>
-                </a:lnSpc>
-                <a:spcBef>
-                  <a:spcPct val="0"/>
-                </a:spcBef>
-              </a:pPr>
-              <a:endParaRPr/>
-            </a:p>
-          </p:txBody>
-        </p:sp>
-      </p:grpSp>
-      <p:grpSp>
-        <p:nvGrpSpPr>
-          <p:cNvPr id="12" name="Group 12"/>
-          <p:cNvGrpSpPr/>
-          <p:nvPr/>
-        </p:nvGrpSpPr>
-        <p:grpSpPr>
-          <a:xfrm>
-            <a:off x="9695177" y="1672088"/>
-            <a:ext cx="8592823" cy="3635707"/>
+            <a:off x="9695177" y="6910501"/>
+            <a:ext cx="8592823" cy="3415292"/>
             <a:chOff x="0" y="0"/>
             <a:chExt cx="2263130" cy="957552"/>
           </a:xfrm>
@@ -6881,15 +6784,15 @@
         </p:nvSpPr>
         <p:spPr>
           <a:xfrm>
-            <a:off x="9847017" y="1824488"/>
-            <a:ext cx="1227609" cy="297180"/>
+            <a:off x="9549282" y="1673398"/>
+            <a:ext cx="1659183" cy="300082"/>
           </a:xfrm>
           <a:prstGeom prst="rect">
             <a:avLst/>
           </a:prstGeom>
         </p:spPr>
         <p:txBody>
-          <a:bodyPr lIns="0" tIns="0" rIns="0" bIns="0" rtlCol="0" anchor="t">
+          <a:bodyPr wrap="square" lIns="0" tIns="0" rIns="0" bIns="0" rtlCol="0" anchor="t">
             <a:spAutoFit/>
           </a:bodyPr>
           <a:lstStyle/>
@@ -6903,7 +6806,7 @@
               </a:spcBef>
             </a:pPr>
             <a:r>
-              <a:rPr lang="en-US" sz="1800">
+              <a:rPr lang="en-US" sz="1800" dirty="0">
                 <a:solidFill>
                   <a:srgbClr val="000000"/>
                 </a:solidFill>
@@ -6969,7 +6872,7 @@
         </p:nvSpPr>
         <p:spPr>
           <a:xfrm>
-            <a:off x="9847017" y="5479245"/>
+            <a:off x="9793279" y="7000629"/>
             <a:ext cx="3940022" cy="297180"/>
           </a:xfrm>
           <a:prstGeom prst="rect">
@@ -6991,7 +6894,7 @@
               </a:spcBef>
             </a:pPr>
             <a:r>
-              <a:rPr lang="en-US" sz="1800">
+              <a:rPr lang="en-US" sz="1800" dirty="0">
                 <a:solidFill>
                   <a:srgbClr val="000000"/>
                 </a:solidFill>
@@ -7401,15 +7304,15 @@
         </p:nvSpPr>
         <p:spPr>
           <a:xfrm>
-            <a:off x="9780580" y="117926"/>
-            <a:ext cx="543744" cy="297179"/>
+            <a:off x="9780579" y="117926"/>
+            <a:ext cx="981397" cy="300082"/>
           </a:xfrm>
           <a:prstGeom prst="rect">
             <a:avLst/>
           </a:prstGeom>
         </p:spPr>
         <p:txBody>
-          <a:bodyPr lIns="0" tIns="0" rIns="0" bIns="0" rtlCol="0" anchor="t">
+          <a:bodyPr wrap="square" lIns="0" tIns="0" rIns="0" bIns="0" rtlCol="0" anchor="t">
             <a:spAutoFit/>
           </a:bodyPr>
           <a:lstStyle/>
@@ -7423,7 +7326,7 @@
               </a:spcBef>
             </a:pPr>
             <a:r>
-              <a:rPr lang="en-US" sz="1800">
+              <a:rPr lang="en-US" sz="1800" dirty="0">
                 <a:solidFill>
                   <a:srgbClr val="000000"/>
                 </a:solidFill>
@@ -7446,14 +7349,14 @@
         <p:spPr>
           <a:xfrm>
             <a:off x="9780580" y="652888"/>
-            <a:ext cx="825326" cy="297180"/>
+            <a:ext cx="1116020" cy="297180"/>
           </a:xfrm>
           <a:prstGeom prst="rect">
             <a:avLst/>
           </a:prstGeom>
         </p:spPr>
         <p:txBody>
-          <a:bodyPr lIns="0" tIns="0" rIns="0" bIns="0" rtlCol="0" anchor="t">
+          <a:bodyPr wrap="square" lIns="0" tIns="0" rIns="0" bIns="0" rtlCol="0" anchor="t">
             <a:spAutoFit/>
           </a:bodyPr>
           <a:lstStyle/>
@@ -7467,7 +7370,7 @@
               </a:spcBef>
             </a:pPr>
             <a:r>
-              <a:rPr lang="en-US" sz="1800">
+              <a:rPr lang="en-US" sz="1800" dirty="0">
                 <a:solidFill>
                   <a:srgbClr val="000000"/>
                 </a:solidFill>
@@ -7489,15 +7392,15 @@
         </p:nvSpPr>
         <p:spPr>
           <a:xfrm>
-            <a:off x="13556940" y="652888"/>
-            <a:ext cx="583109" cy="297180"/>
+            <a:off x="13556940" y="652887"/>
+            <a:ext cx="844860" cy="300082"/>
           </a:xfrm>
           <a:prstGeom prst="rect">
             <a:avLst/>
           </a:prstGeom>
         </p:spPr>
         <p:txBody>
-          <a:bodyPr lIns="0" tIns="0" rIns="0" bIns="0" rtlCol="0" anchor="t">
+          <a:bodyPr wrap="square" lIns="0" tIns="0" rIns="0" bIns="0" rtlCol="0" anchor="t">
             <a:spAutoFit/>
           </a:bodyPr>
           <a:lstStyle/>
@@ -7511,7 +7414,7 @@
               </a:spcBef>
             </a:pPr>
             <a:r>
-              <a:rPr lang="en-US" sz="1800">
+              <a:rPr lang="en-US" sz="1800" dirty="0">
                 <a:solidFill>
                   <a:srgbClr val="000000"/>
                 </a:solidFill>
@@ -7630,15 +7533,15 @@
         </p:nvSpPr>
         <p:spPr>
           <a:xfrm>
-            <a:off x="16218037" y="652888"/>
-            <a:ext cx="698078" cy="297180"/>
+            <a:off x="16218036" y="652888"/>
+            <a:ext cx="844859" cy="300082"/>
           </a:xfrm>
           <a:prstGeom prst="rect">
             <a:avLst/>
           </a:prstGeom>
         </p:spPr>
         <p:txBody>
-          <a:bodyPr lIns="0" tIns="0" rIns="0" bIns="0" rtlCol="0" anchor="t">
+          <a:bodyPr wrap="square" lIns="0" tIns="0" rIns="0" bIns="0" rtlCol="0" anchor="t">
             <a:spAutoFit/>
           </a:bodyPr>
           <a:lstStyle/>
@@ -7652,7 +7555,7 @@
               </a:spcBef>
             </a:pPr>
             <a:r>
-              <a:rPr lang="en-US" sz="1800">
+              <a:rPr lang="en-US" sz="1800" dirty="0">
                 <a:solidFill>
                   <a:srgbClr val="000000"/>
                 </a:solidFill>
@@ -7675,14 +7578,14 @@
         <p:spPr>
           <a:xfrm>
             <a:off x="9780580" y="1189613"/>
-            <a:ext cx="533772" cy="297180"/>
+            <a:ext cx="887420" cy="300082"/>
           </a:xfrm>
           <a:prstGeom prst="rect">
             <a:avLst/>
           </a:prstGeom>
         </p:spPr>
         <p:txBody>
-          <a:bodyPr lIns="0" tIns="0" rIns="0" bIns="0" rtlCol="0" anchor="t">
+          <a:bodyPr wrap="square" lIns="0" tIns="0" rIns="0" bIns="0" rtlCol="0" anchor="t">
             <a:spAutoFit/>
           </a:bodyPr>
           <a:lstStyle/>
@@ -7696,7 +7599,7 @@
               </a:spcBef>
             </a:pPr>
             <a:r>
-              <a:rPr lang="en-US" sz="1800">
+              <a:rPr lang="en-US" sz="1800" dirty="0">
                 <a:solidFill>
                   <a:srgbClr val="000000"/>
                 </a:solidFill>
@@ -7707,6 +7610,2087 @@
               </a:rPr>
               <a:t>Task:</a:t>
             </a:r>
+          </a:p>
+        </p:txBody>
+      </p:sp>
+      <p:pic>
+        <p:nvPicPr>
+          <p:cNvPr id="41" name="圖片 40">
+            <a:extLst>
+              <a:ext uri="{FF2B5EF4-FFF2-40B4-BE49-F238E27FC236}">
+                <a16:creationId xmlns:a16="http://schemas.microsoft.com/office/drawing/2014/main" id="{D278EC06-E08B-C696-7254-FB49344AF5E1}"/>
+              </a:ext>
+            </a:extLst>
+          </p:cNvPr>
+          <p:cNvPicPr>
+            <a:picLocks noChangeAspect="1"/>
+          </p:cNvPicPr>
+          <p:nvPr/>
+        </p:nvPicPr>
+        <p:blipFill>
+          <a:blip r:embed="rId2">
+            <a:extLst>
+              <a:ext uri="{28A0092B-C50C-407E-A947-70E740481C1C}">
+                <a14:useLocalDpi xmlns:a14="http://schemas.microsoft.com/office/drawing/2010/main" val="0"/>
+              </a:ext>
+            </a:extLst>
+          </a:blip>
+          <a:srcRect l="12702"/>
+          <a:stretch>
+            <a:fillRect/>
+          </a:stretch>
+        </p:blipFill>
+        <p:spPr>
+          <a:xfrm>
+            <a:off x="6537441" y="3902973"/>
+            <a:ext cx="1790344" cy="1311843"/>
+          </a:xfrm>
+          <a:prstGeom prst="rect">
+            <a:avLst/>
+          </a:prstGeom>
+        </p:spPr>
+      </p:pic>
+      <p:pic>
+        <p:nvPicPr>
+          <p:cNvPr id="43" name="圖片 42">
+            <a:extLst>
+              <a:ext uri="{FF2B5EF4-FFF2-40B4-BE49-F238E27FC236}">
+                <a16:creationId xmlns:a16="http://schemas.microsoft.com/office/drawing/2014/main" id="{87D49D0D-21AE-2FB7-6634-54CF6CE5B57C}"/>
+              </a:ext>
+            </a:extLst>
+          </p:cNvPr>
+          <p:cNvPicPr>
+            <a:picLocks noChangeAspect="1"/>
+          </p:cNvPicPr>
+          <p:nvPr/>
+        </p:nvPicPr>
+        <p:blipFill>
+          <a:blip r:embed="rId3">
+            <a:extLst>
+              <a:ext uri="{28A0092B-C50C-407E-A947-70E740481C1C}">
+                <a14:useLocalDpi xmlns:a14="http://schemas.microsoft.com/office/drawing/2010/main" val="0"/>
+              </a:ext>
+            </a:extLst>
+          </a:blip>
+          <a:stretch>
+            <a:fillRect/>
+          </a:stretch>
+        </p:blipFill>
+        <p:spPr>
+          <a:xfrm>
+            <a:off x="6130248" y="1490647"/>
+            <a:ext cx="1690758" cy="1511292"/>
+          </a:xfrm>
+          <a:prstGeom prst="rect">
+            <a:avLst/>
+          </a:prstGeom>
+        </p:spPr>
+      </p:pic>
+      <p:pic>
+        <p:nvPicPr>
+          <p:cNvPr id="47" name="圖片 46">
+            <a:extLst>
+              <a:ext uri="{FF2B5EF4-FFF2-40B4-BE49-F238E27FC236}">
+                <a16:creationId xmlns:a16="http://schemas.microsoft.com/office/drawing/2014/main" id="{72895365-49BF-8EA6-660F-4DCC582CEF03}"/>
+              </a:ext>
+            </a:extLst>
+          </p:cNvPr>
+          <p:cNvPicPr>
+            <a:picLocks noChangeAspect="1"/>
+          </p:cNvPicPr>
+          <p:nvPr/>
+        </p:nvPicPr>
+        <p:blipFill>
+          <a:blip r:embed="rId4">
+            <a:extLst>
+              <a:ext uri="{28A0092B-C50C-407E-A947-70E740481C1C}">
+                <a14:useLocalDpi xmlns:a14="http://schemas.microsoft.com/office/drawing/2010/main" val="0"/>
+              </a:ext>
+            </a:extLst>
+          </a:blip>
+          <a:stretch>
+            <a:fillRect/>
+          </a:stretch>
+        </p:blipFill>
+        <p:spPr>
+          <a:xfrm>
+            <a:off x="6946263" y="5274988"/>
+            <a:ext cx="1790344" cy="1391713"/>
+          </a:xfrm>
+          <a:prstGeom prst="rect">
+            <a:avLst/>
+          </a:prstGeom>
+        </p:spPr>
+      </p:pic>
+      <p:grpSp>
+        <p:nvGrpSpPr>
+          <p:cNvPr id="103" name="群組 102">
+            <a:extLst>
+              <a:ext uri="{FF2B5EF4-FFF2-40B4-BE49-F238E27FC236}">
+                <a16:creationId xmlns:a16="http://schemas.microsoft.com/office/drawing/2014/main" id="{DF5B0B4D-639F-F572-6C1C-DE494C96F30C}"/>
+              </a:ext>
+            </a:extLst>
+          </p:cNvPr>
+          <p:cNvGrpSpPr/>
+          <p:nvPr/>
+        </p:nvGrpSpPr>
+        <p:grpSpPr>
+          <a:xfrm>
+            <a:off x="7649499" y="2623935"/>
+            <a:ext cx="1729769" cy="1285740"/>
+            <a:chOff x="6467731" y="2801152"/>
+            <a:chExt cx="1457069" cy="1013663"/>
+          </a:xfrm>
+        </p:grpSpPr>
+        <p:pic>
+          <p:nvPicPr>
+            <p:cNvPr id="45" name="圖片 44">
+              <a:extLst>
+                <a:ext uri="{FF2B5EF4-FFF2-40B4-BE49-F238E27FC236}">
+                  <a16:creationId xmlns:a16="http://schemas.microsoft.com/office/drawing/2014/main" id="{5750988D-9C38-BAB9-0898-04EB9D24A545}"/>
+                </a:ext>
+              </a:extLst>
+            </p:cNvPr>
+            <p:cNvPicPr>
+              <a:picLocks noChangeAspect="1"/>
+            </p:cNvPicPr>
+            <p:nvPr/>
+          </p:nvPicPr>
+          <p:blipFill>
+            <a:blip r:embed="rId5">
+              <a:extLst>
+                <a:ext uri="{28A0092B-C50C-407E-A947-70E740481C1C}">
+                  <a14:useLocalDpi xmlns:a14="http://schemas.microsoft.com/office/drawing/2010/main" val="0"/>
+                </a:ext>
+              </a:extLst>
+            </a:blip>
+            <a:srcRect r="46056"/>
+            <a:stretch>
+              <a:fillRect/>
+            </a:stretch>
+          </p:blipFill>
+          <p:spPr>
+            <a:xfrm>
+              <a:off x="6467731" y="2801152"/>
+              <a:ext cx="999595" cy="1013663"/>
+            </a:xfrm>
+            <a:prstGeom prst="rect">
+              <a:avLst/>
+            </a:prstGeom>
+          </p:spPr>
+        </p:pic>
+        <p:sp>
+          <p:nvSpPr>
+            <p:cNvPr id="60" name="矩形 59">
+              <a:extLst>
+                <a:ext uri="{FF2B5EF4-FFF2-40B4-BE49-F238E27FC236}">
+                  <a16:creationId xmlns:a16="http://schemas.microsoft.com/office/drawing/2014/main" id="{96F5B227-F902-E4B3-F0BC-A47B08D638AE}"/>
+                </a:ext>
+              </a:extLst>
+            </p:cNvPr>
+            <p:cNvSpPr/>
+            <p:nvPr/>
+          </p:nvSpPr>
+          <p:spPr>
+            <a:xfrm>
+              <a:off x="7323844" y="3102420"/>
+              <a:ext cx="600956" cy="124154"/>
+            </a:xfrm>
+            <a:prstGeom prst="rect">
+              <a:avLst/>
+            </a:prstGeom>
+            <a:solidFill>
+              <a:schemeClr val="bg1"/>
+            </a:solidFill>
+            <a:ln w="6350">
+              <a:solidFill>
+                <a:schemeClr val="tx1"/>
+              </a:solidFill>
+            </a:ln>
+          </p:spPr>
+          <p:style>
+            <a:lnRef idx="2">
+              <a:schemeClr val="accent1">
+                <a:shade val="15000"/>
+              </a:schemeClr>
+            </a:lnRef>
+            <a:fillRef idx="1">
+              <a:schemeClr val="accent1"/>
+            </a:fillRef>
+            <a:effectRef idx="0">
+              <a:schemeClr val="accent1"/>
+            </a:effectRef>
+            <a:fontRef idx="minor">
+              <a:schemeClr val="lt1"/>
+            </a:fontRef>
+          </p:style>
+          <p:txBody>
+            <a:bodyPr rtlCol="0" anchor="ctr"/>
+            <a:lstStyle/>
+            <a:p>
+              <a:pPr algn="ctr"/>
+              <a:r>
+                <a:rPr lang="en-US" altLang="zh-HK" sz="300" dirty="0">
+                  <a:ln w="0"/>
+                  <a:solidFill>
+                    <a:schemeClr val="tx1"/>
+                  </a:solidFill>
+                </a:rPr>
+                <a:t>School name+ type</a:t>
+              </a:r>
+              <a:br>
+                <a:rPr lang="en-US" altLang="zh-HK" sz="300" dirty="0">
+                  <a:ln w="0"/>
+                  <a:solidFill>
+                    <a:schemeClr val="tx1"/>
+                  </a:solidFill>
+                </a:rPr>
+              </a:br>
+              <a:r>
+                <a:rPr lang="zh-HK" altLang="zh-HK" sz="300" b="1" dirty="0">
+                  <a:solidFill>
+                    <a:schemeClr val="tx1"/>
+                  </a:solidFill>
+                </a:rPr>
+                <a:t>See its three-year trend</a:t>
+              </a:r>
+              <a:endParaRPr lang="zh-HK" altLang="en-US" sz="300" dirty="0">
+                <a:solidFill>
+                  <a:schemeClr val="tx1"/>
+                </a:solidFill>
+              </a:endParaRPr>
+            </a:p>
+          </p:txBody>
+        </p:sp>
+        <p:pic>
+          <p:nvPicPr>
+            <p:cNvPr id="62" name="圖片 61">
+              <a:extLst>
+                <a:ext uri="{FF2B5EF4-FFF2-40B4-BE49-F238E27FC236}">
+                  <a16:creationId xmlns:a16="http://schemas.microsoft.com/office/drawing/2014/main" id="{83724F94-AD85-A0D1-2D4B-CE6B53CD87DE}"/>
+                </a:ext>
+              </a:extLst>
+            </p:cNvPr>
+            <p:cNvPicPr>
+              <a:picLocks noChangeAspect="1"/>
+            </p:cNvPicPr>
+            <p:nvPr/>
+          </p:nvPicPr>
+          <p:blipFill>
+            <a:blip r:embed="rId5">
+              <a:extLst>
+                <a:ext uri="{28A0092B-C50C-407E-A947-70E740481C1C}">
+                  <a14:useLocalDpi xmlns:a14="http://schemas.microsoft.com/office/drawing/2010/main" val="0"/>
+                </a:ext>
+              </a:extLst>
+            </a:blip>
+            <a:srcRect l="58027" t="24395" r="5900" b="21499"/>
+            <a:stretch>
+              <a:fillRect/>
+            </a:stretch>
+          </p:blipFill>
+          <p:spPr>
+            <a:xfrm>
+              <a:off x="7328885" y="3243032"/>
+              <a:ext cx="509749" cy="418248"/>
+            </a:xfrm>
+            <a:prstGeom prst="rect">
+              <a:avLst/>
+            </a:prstGeom>
+          </p:spPr>
+        </p:pic>
+        <p:sp>
+          <p:nvSpPr>
+            <p:cNvPr id="63" name="矩形 62">
+              <a:extLst>
+                <a:ext uri="{FF2B5EF4-FFF2-40B4-BE49-F238E27FC236}">
+                  <a16:creationId xmlns:a16="http://schemas.microsoft.com/office/drawing/2014/main" id="{1DD0387F-A2E4-394E-161D-5D4449A021B8}"/>
+                </a:ext>
+              </a:extLst>
+            </p:cNvPr>
+            <p:cNvSpPr/>
+            <p:nvPr/>
+          </p:nvSpPr>
+          <p:spPr>
+            <a:xfrm>
+              <a:off x="7385303" y="3164497"/>
+              <a:ext cx="37785" cy="45719"/>
+            </a:xfrm>
+            <a:prstGeom prst="rect">
+              <a:avLst/>
+            </a:prstGeom>
+            <a:ln w="3175"/>
+          </p:spPr>
+          <p:style>
+            <a:lnRef idx="2">
+              <a:schemeClr val="accent1">
+                <a:shade val="15000"/>
+              </a:schemeClr>
+            </a:lnRef>
+            <a:fillRef idx="1">
+              <a:schemeClr val="accent1"/>
+            </a:fillRef>
+            <a:effectRef idx="0">
+              <a:schemeClr val="accent1"/>
+            </a:effectRef>
+            <a:fontRef idx="minor">
+              <a:schemeClr val="lt1"/>
+            </a:fontRef>
+          </p:style>
+          <p:txBody>
+            <a:bodyPr rtlCol="0" anchor="ctr"/>
+            <a:lstStyle/>
+            <a:p>
+              <a:pPr algn="ctr"/>
+              <a:endParaRPr lang="zh-HK" altLang="en-US">
+                <a:ln w="0"/>
+                <a:solidFill>
+                  <a:schemeClr val="tx1"/>
+                </a:solidFill>
+                <a:effectLst>
+                  <a:outerShdw blurRad="38100" dist="19050" dir="2700000" algn="tl" rotWithShape="0">
+                    <a:schemeClr val="dk1">
+                      <a:alpha val="40000"/>
+                    </a:schemeClr>
+                  </a:outerShdw>
+                </a:effectLst>
+              </a:endParaRPr>
+            </a:p>
+          </p:txBody>
+        </p:sp>
+        <p:sp>
+          <p:nvSpPr>
+            <p:cNvPr id="64" name="手繪多邊形: 圖案 63">
+              <a:extLst>
+                <a:ext uri="{FF2B5EF4-FFF2-40B4-BE49-F238E27FC236}">
+                  <a16:creationId xmlns:a16="http://schemas.microsoft.com/office/drawing/2014/main" id="{38173A6B-345D-E904-D3DE-FAC0BED6379E}"/>
+                </a:ext>
+              </a:extLst>
+            </p:cNvPr>
+            <p:cNvSpPr/>
+            <p:nvPr/>
+          </p:nvSpPr>
+          <p:spPr>
+            <a:xfrm>
+              <a:off x="7393781" y="3157538"/>
+              <a:ext cx="47625" cy="43499"/>
+            </a:xfrm>
+            <a:custGeom>
+              <a:avLst/>
+              <a:gdLst>
+                <a:gd name="csX0" fmla="*/ 0 w 47625"/>
+                <a:gd name="csY0" fmla="*/ 28575 h 43499"/>
+                <a:gd name="csX1" fmla="*/ 35719 w 47625"/>
+                <a:gd name="csY1" fmla="*/ 14287 h 43499"/>
+                <a:gd name="csX2" fmla="*/ 47625 w 47625"/>
+                <a:gd name="csY2" fmla="*/ 0 h 43499"/>
+              </a:gdLst>
+              <a:ahLst/>
+              <a:cxnLst>
+                <a:cxn ang="0">
+                  <a:pos x="csX0" y="csY0"/>
+                </a:cxn>
+                <a:cxn ang="0">
+                  <a:pos x="csX1" y="csY1"/>
+                </a:cxn>
+                <a:cxn ang="0">
+                  <a:pos x="csX2" y="csY2"/>
+                </a:cxn>
+              </a:cxnLst>
+              <a:rect l="l" t="t" r="r" b="b"/>
+              <a:pathLst>
+                <a:path w="47625" h="43499">
+                  <a:moveTo>
+                    <a:pt x="0" y="28575"/>
+                  </a:moveTo>
+                  <a:cubicBezTo>
+                    <a:pt x="4961" y="53372"/>
+                    <a:pt x="-125" y="46358"/>
+                    <a:pt x="35719" y="14287"/>
+                  </a:cubicBezTo>
+                  <a:cubicBezTo>
+                    <a:pt x="40339" y="10153"/>
+                    <a:pt x="47625" y="0"/>
+                    <a:pt x="47625" y="0"/>
+                  </a:cubicBezTo>
+                </a:path>
+              </a:pathLst>
+            </a:custGeom>
+            <a:ln w="3175"/>
+          </p:spPr>
+          <p:style>
+            <a:lnRef idx="1">
+              <a:schemeClr val="dk1"/>
+            </a:lnRef>
+            <a:fillRef idx="0">
+              <a:schemeClr val="dk1"/>
+            </a:fillRef>
+            <a:effectRef idx="0">
+              <a:schemeClr val="dk1"/>
+            </a:effectRef>
+            <a:fontRef idx="minor">
+              <a:schemeClr val="tx1"/>
+            </a:fontRef>
+          </p:style>
+          <p:txBody>
+            <a:bodyPr rtlCol="0" anchor="ctr"/>
+            <a:lstStyle/>
+            <a:p>
+              <a:pPr algn="ctr"/>
+              <a:endParaRPr lang="zh-HK" altLang="en-US"/>
+            </a:p>
+          </p:txBody>
+        </p:sp>
+      </p:grpSp>
+      <p:pic>
+        <p:nvPicPr>
+          <p:cNvPr id="68" name="圖片 67">
+            <a:extLst>
+              <a:ext uri="{FF2B5EF4-FFF2-40B4-BE49-F238E27FC236}">
+                <a16:creationId xmlns:a16="http://schemas.microsoft.com/office/drawing/2014/main" id="{9F464E21-BEA6-21B4-7A05-4FBCB06D867A}"/>
+              </a:ext>
+            </a:extLst>
+          </p:cNvPr>
+          <p:cNvPicPr>
+            <a:picLocks noChangeAspect="1"/>
+          </p:cNvPicPr>
+          <p:nvPr/>
+        </p:nvPicPr>
+        <p:blipFill>
+          <a:blip r:embed="rId6"/>
+          <a:srcRect l="4872" t="59593" r="38610"/>
+          <a:stretch>
+            <a:fillRect/>
+          </a:stretch>
+        </p:blipFill>
+        <p:spPr>
+          <a:xfrm>
+            <a:off x="7729294" y="4394821"/>
+            <a:ext cx="914400" cy="508455"/>
+          </a:xfrm>
+          <a:prstGeom prst="rect">
+            <a:avLst/>
+          </a:prstGeom>
+        </p:spPr>
+      </p:pic>
+      <p:sp>
+        <p:nvSpPr>
+          <p:cNvPr id="69" name="文字方塊 68">
+            <a:extLst>
+              <a:ext uri="{FF2B5EF4-FFF2-40B4-BE49-F238E27FC236}">
+                <a16:creationId xmlns:a16="http://schemas.microsoft.com/office/drawing/2014/main" id="{5B4A993B-2BB4-ABAE-9B94-E315D1B3D234}"/>
+              </a:ext>
+            </a:extLst>
+          </p:cNvPr>
+          <p:cNvSpPr txBox="1"/>
+          <p:nvPr/>
+        </p:nvSpPr>
+        <p:spPr>
+          <a:xfrm>
+            <a:off x="7624322" y="4858445"/>
+            <a:ext cx="1854627" cy="276999"/>
+          </a:xfrm>
+          <a:prstGeom prst="rect">
+            <a:avLst/>
+          </a:prstGeom>
+          <a:noFill/>
+        </p:spPr>
+        <p:txBody>
+          <a:bodyPr wrap="square" rtlCol="0">
+            <a:spAutoFit/>
+          </a:bodyPr>
+          <a:lstStyle/>
+          <a:p>
+            <a:r>
+              <a:rPr lang="zh-HK" altLang="zh-HK" sz="1200" dirty="0"/>
+              <a:t>Where are these schools</a:t>
+            </a:r>
+            <a:r>
+              <a:rPr lang="en-US" altLang="zh-HK" sz="1200" dirty="0"/>
+              <a:t>?</a:t>
+            </a:r>
+            <a:endParaRPr lang="zh-HK" altLang="en-US" sz="1200" dirty="0"/>
+          </a:p>
+        </p:txBody>
+      </p:sp>
+      <p:sp>
+        <p:nvSpPr>
+          <p:cNvPr id="73" name="文字方塊 72">
+            <a:extLst>
+              <a:ext uri="{FF2B5EF4-FFF2-40B4-BE49-F238E27FC236}">
+                <a16:creationId xmlns:a16="http://schemas.microsoft.com/office/drawing/2014/main" id="{E93B9360-DE2E-DAED-DD73-0AD3799261E7}"/>
+              </a:ext>
+            </a:extLst>
+          </p:cNvPr>
+          <p:cNvSpPr txBox="1"/>
+          <p:nvPr/>
+        </p:nvSpPr>
+        <p:spPr>
+          <a:xfrm>
+            <a:off x="244237" y="3259594"/>
+            <a:ext cx="6205804" cy="646331"/>
+          </a:xfrm>
+          <a:prstGeom prst="rect">
+            <a:avLst/>
+          </a:prstGeom>
+          <a:noFill/>
+        </p:spPr>
+        <p:txBody>
+          <a:bodyPr wrap="square">
+            <a:spAutoFit/>
+          </a:bodyPr>
+          <a:lstStyle/>
+          <a:p>
+            <a:r>
+              <a:rPr lang="zh-HK" altLang="zh-HK" b="1" u="sng" dirty="0"/>
+              <a:t>Scroll through results, regional options, student backgrounds and recent trends. Finish with school-zone details.</a:t>
+            </a:r>
+            <a:endParaRPr lang="zh-HK" altLang="en-US" b="1" u="sng" dirty="0"/>
+          </a:p>
+        </p:txBody>
+      </p:sp>
+      <p:pic>
+        <p:nvPicPr>
+          <p:cNvPr id="77" name="圖片 76">
+            <a:extLst>
+              <a:ext uri="{FF2B5EF4-FFF2-40B4-BE49-F238E27FC236}">
+                <a16:creationId xmlns:a16="http://schemas.microsoft.com/office/drawing/2014/main" id="{B96B0CC9-7D33-DF34-A92A-6B45FED5137A}"/>
+              </a:ext>
+            </a:extLst>
+          </p:cNvPr>
+          <p:cNvPicPr>
+            <a:picLocks noChangeAspect="1"/>
+          </p:cNvPicPr>
+          <p:nvPr/>
+        </p:nvPicPr>
+        <p:blipFill>
+          <a:blip r:embed="rId7"/>
+          <a:stretch>
+            <a:fillRect/>
+          </a:stretch>
+        </p:blipFill>
+        <p:spPr>
+          <a:xfrm>
+            <a:off x="791498" y="900823"/>
+            <a:ext cx="4724824" cy="2403713"/>
+          </a:xfrm>
+          <a:prstGeom prst="rect">
+            <a:avLst/>
+          </a:prstGeom>
+        </p:spPr>
+      </p:pic>
+      <p:sp>
+        <p:nvSpPr>
+          <p:cNvPr id="80" name="矩形 79">
+            <a:extLst>
+              <a:ext uri="{FF2B5EF4-FFF2-40B4-BE49-F238E27FC236}">
+                <a16:creationId xmlns:a16="http://schemas.microsoft.com/office/drawing/2014/main" id="{9E836B5B-80A3-344B-CFFC-0066633A2EDC}"/>
+              </a:ext>
+            </a:extLst>
+          </p:cNvPr>
+          <p:cNvSpPr/>
+          <p:nvPr/>
+        </p:nvSpPr>
+        <p:spPr>
+          <a:xfrm>
+            <a:off x="518650" y="875249"/>
+            <a:ext cx="5126999" cy="2273855"/>
+          </a:xfrm>
+          <a:prstGeom prst="rect">
+            <a:avLst/>
+          </a:prstGeom>
+          <a:noFill/>
+        </p:spPr>
+        <p:style>
+          <a:lnRef idx="2">
+            <a:schemeClr val="accent1">
+              <a:shade val="15000"/>
+            </a:schemeClr>
+          </a:lnRef>
+          <a:fillRef idx="1">
+            <a:schemeClr val="accent1"/>
+          </a:fillRef>
+          <a:effectRef idx="0">
+            <a:schemeClr val="accent1"/>
+          </a:effectRef>
+          <a:fontRef idx="minor">
+            <a:schemeClr val="lt1"/>
+          </a:fontRef>
+        </p:style>
+        <p:txBody>
+          <a:bodyPr rtlCol="0" anchor="ctr"/>
+          <a:lstStyle/>
+          <a:p>
+            <a:pPr algn="ctr"/>
+            <a:endParaRPr lang="zh-HK" altLang="en-US"/>
+          </a:p>
+        </p:txBody>
+      </p:sp>
+      <p:pic>
+        <p:nvPicPr>
+          <p:cNvPr id="82" name="圖片 81">
+            <a:extLst>
+              <a:ext uri="{FF2B5EF4-FFF2-40B4-BE49-F238E27FC236}">
+                <a16:creationId xmlns:a16="http://schemas.microsoft.com/office/drawing/2014/main" id="{69F92E4E-A900-B3DE-2194-1C770D77EC33}"/>
+              </a:ext>
+            </a:extLst>
+          </p:cNvPr>
+          <p:cNvPicPr>
+            <a:picLocks noChangeAspect="1"/>
+          </p:cNvPicPr>
+          <p:nvPr/>
+        </p:nvPicPr>
+        <p:blipFill>
+          <a:blip r:embed="rId8"/>
+          <a:srcRect b="10614"/>
+          <a:stretch>
+            <a:fillRect/>
+          </a:stretch>
+        </p:blipFill>
+        <p:spPr>
+          <a:xfrm>
+            <a:off x="935756" y="1375967"/>
+            <a:ext cx="2192754" cy="1466583"/>
+          </a:xfrm>
+          <a:prstGeom prst="rect">
+            <a:avLst/>
+          </a:prstGeom>
+        </p:spPr>
+      </p:pic>
+      <p:grpSp>
+        <p:nvGrpSpPr>
+          <p:cNvPr id="102" name="群組 101">
+            <a:extLst>
+              <a:ext uri="{FF2B5EF4-FFF2-40B4-BE49-F238E27FC236}">
+                <a16:creationId xmlns:a16="http://schemas.microsoft.com/office/drawing/2014/main" id="{F08AEEA6-2D02-36DC-AB23-0298EAE18A92}"/>
+              </a:ext>
+            </a:extLst>
+          </p:cNvPr>
+          <p:cNvGrpSpPr/>
+          <p:nvPr/>
+        </p:nvGrpSpPr>
+        <p:grpSpPr>
+          <a:xfrm>
+            <a:off x="7480481" y="325416"/>
+            <a:ext cx="2128971" cy="1408848"/>
+            <a:chOff x="6662426" y="284834"/>
+            <a:chExt cx="1732581" cy="1213191"/>
+          </a:xfrm>
+        </p:grpSpPr>
+        <p:pic>
+          <p:nvPicPr>
+            <p:cNvPr id="79" name="圖片 78">
+              <a:extLst>
+                <a:ext uri="{FF2B5EF4-FFF2-40B4-BE49-F238E27FC236}">
+                  <a16:creationId xmlns:a16="http://schemas.microsoft.com/office/drawing/2014/main" id="{0AAD1700-20F6-7FEC-EC75-7DE39C229548}"/>
+                </a:ext>
+              </a:extLst>
+            </p:cNvPr>
+            <p:cNvPicPr>
+              <a:picLocks noChangeAspect="1"/>
+            </p:cNvPicPr>
+            <p:nvPr/>
+          </p:nvPicPr>
+          <p:blipFill>
+            <a:blip r:embed="rId8"/>
+            <a:srcRect b="10614"/>
+            <a:stretch>
+              <a:fillRect/>
+            </a:stretch>
+          </p:blipFill>
+          <p:spPr>
+            <a:xfrm>
+              <a:off x="6662426" y="284834"/>
+              <a:ext cx="1418307" cy="1213191"/>
+            </a:xfrm>
+            <a:prstGeom prst="rect">
+              <a:avLst/>
+            </a:prstGeom>
+          </p:spPr>
+        </p:pic>
+        <p:sp>
+          <p:nvSpPr>
+            <p:cNvPr id="83" name="流程圖: 接點 82">
+              <a:extLst>
+                <a:ext uri="{FF2B5EF4-FFF2-40B4-BE49-F238E27FC236}">
+                  <a16:creationId xmlns:a16="http://schemas.microsoft.com/office/drawing/2014/main" id="{23586336-4F6C-2E40-0F6B-341082909CAB}"/>
+                </a:ext>
+              </a:extLst>
+            </p:cNvPr>
+            <p:cNvSpPr/>
+            <p:nvPr/>
+          </p:nvSpPr>
+          <p:spPr>
+            <a:xfrm>
+              <a:off x="7448452" y="922892"/>
+              <a:ext cx="200759" cy="188351"/>
+            </a:xfrm>
+            <a:prstGeom prst="flowChartConnector">
+              <a:avLst/>
+            </a:prstGeom>
+          </p:spPr>
+          <p:style>
+            <a:lnRef idx="2">
+              <a:schemeClr val="accent6">
+                <a:shade val="15000"/>
+              </a:schemeClr>
+            </a:lnRef>
+            <a:fillRef idx="1">
+              <a:schemeClr val="accent6"/>
+            </a:fillRef>
+            <a:effectRef idx="0">
+              <a:schemeClr val="accent6"/>
+            </a:effectRef>
+            <a:fontRef idx="minor">
+              <a:schemeClr val="lt1"/>
+            </a:fontRef>
+          </p:style>
+          <p:txBody>
+            <a:bodyPr rtlCol="0" anchor="ctr"/>
+            <a:lstStyle/>
+            <a:p>
+              <a:pPr algn="ctr"/>
+              <a:endParaRPr lang="zh-HK" altLang="en-US"/>
+            </a:p>
+          </p:txBody>
+        </p:sp>
+        <p:sp>
+          <p:nvSpPr>
+            <p:cNvPr id="84" name="圖說文字: 直線 83">
+              <a:extLst>
+                <a:ext uri="{FF2B5EF4-FFF2-40B4-BE49-F238E27FC236}">
+                  <a16:creationId xmlns:a16="http://schemas.microsoft.com/office/drawing/2014/main" id="{6EF1D37A-08FA-11C2-E8E9-E5B8ECF87A39}"/>
+                </a:ext>
+              </a:extLst>
+            </p:cNvPr>
+            <p:cNvSpPr/>
+            <p:nvPr/>
+          </p:nvSpPr>
+          <p:spPr>
+            <a:xfrm>
+              <a:off x="7826672" y="659978"/>
+              <a:ext cx="568335" cy="258407"/>
+            </a:xfrm>
+            <a:prstGeom prst="borderCallout1">
+              <a:avLst/>
+            </a:prstGeom>
+            <a:noFill/>
+            <a:ln w="3175"/>
+          </p:spPr>
+          <p:style>
+            <a:lnRef idx="2">
+              <a:schemeClr val="accent1">
+                <a:shade val="15000"/>
+              </a:schemeClr>
+            </a:lnRef>
+            <a:fillRef idx="1">
+              <a:schemeClr val="accent1"/>
+            </a:fillRef>
+            <a:effectRef idx="0">
+              <a:schemeClr val="accent1"/>
+            </a:effectRef>
+            <a:fontRef idx="minor">
+              <a:schemeClr val="lt1"/>
+            </a:fontRef>
+          </p:style>
+          <p:txBody>
+            <a:bodyPr rtlCol="0" anchor="ctr"/>
+            <a:lstStyle/>
+            <a:p>
+              <a:pPr algn="ctr"/>
+              <a:endParaRPr lang="zh-HK" altLang="en-US"/>
+            </a:p>
+          </p:txBody>
+        </p:sp>
+      </p:grpSp>
+      <p:sp>
+        <p:nvSpPr>
+          <p:cNvPr id="86" name="文字方塊 85">
+            <a:extLst>
+              <a:ext uri="{FF2B5EF4-FFF2-40B4-BE49-F238E27FC236}">
+                <a16:creationId xmlns:a16="http://schemas.microsoft.com/office/drawing/2014/main" id="{29CDC686-FDB7-E681-9D6F-E1039521536E}"/>
+              </a:ext>
+            </a:extLst>
+          </p:cNvPr>
+          <p:cNvSpPr txBox="1"/>
+          <p:nvPr/>
+        </p:nvSpPr>
+        <p:spPr>
+          <a:xfrm>
+            <a:off x="9695177" y="2028839"/>
+            <a:ext cx="8404183" cy="4708981"/>
+          </a:xfrm>
+          <a:prstGeom prst="rect">
+            <a:avLst/>
+          </a:prstGeom>
+          <a:noFill/>
+        </p:spPr>
+        <p:txBody>
+          <a:bodyPr wrap="square">
+            <a:spAutoFit/>
+          </a:bodyPr>
+          <a:lstStyle/>
+          <a:p>
+            <a:pPr marL="228600" indent="-228600">
+              <a:buAutoNum type="arabicPeriod"/>
+            </a:pPr>
+            <a:r>
+              <a:rPr lang="zh-HK" altLang="zh-HK" sz="1200" b="1" dirty="0"/>
+              <a:t>Results:</a:t>
+            </a:r>
+            <a:r>
+              <a:rPr lang="zh-HK" altLang="zh-HK" sz="1200" dirty="0"/>
+              <a:t> </a:t>
+            </a:r>
+            <a:endParaRPr lang="en-US" altLang="zh-HK" sz="1200" dirty="0"/>
+          </a:p>
+          <a:p>
+            <a:pPr marL="342900" lvl="0" indent="-342900">
+              <a:buFont typeface="Arial" panose="020B0604020202020204" pitchFamily="34" charset="0"/>
+              <a:buChar char="•"/>
+            </a:pPr>
+            <a:r>
+              <a:rPr lang="zh-HK" altLang="zh-HK" sz="1200" dirty="0"/>
+              <a:t>Scroll down: government-school dots remain highlighted while other sectors fade.</a:t>
+            </a:r>
+          </a:p>
+          <a:p>
+            <a:pPr marL="342900" lvl="0" indent="-342900">
+              <a:buFont typeface="Arial" panose="020B0604020202020204" pitchFamily="34" charset="0"/>
+              <a:buChar char="•"/>
+            </a:pPr>
+            <a:r>
+              <a:rPr lang="zh-HK" altLang="zh-HK" sz="1200" dirty="0"/>
+              <a:t>A short transition introduces the public-school focus.</a:t>
+            </a:r>
+          </a:p>
+          <a:p>
+            <a:pPr>
+              <a:buNone/>
+            </a:pPr>
+            <a:r>
+              <a:rPr lang="zh-HK" altLang="zh-HK" sz="1200" b="1" dirty="0"/>
+              <a:t>2. Location:</a:t>
+            </a:r>
+            <a:endParaRPr lang="en-US" altLang="zh-HK" sz="1200" b="1" dirty="0"/>
+          </a:p>
+          <a:p>
+            <a:pPr marL="342900" lvl="0" indent="-342900">
+              <a:buFont typeface="Arial" panose="020B0604020202020204" pitchFamily="34" charset="0"/>
+              <a:buChar char="•"/>
+            </a:pPr>
+            <a:r>
+              <a:rPr lang="zh-HK" altLang="zh-HK" sz="1200" dirty="0"/>
+              <a:t>Switch between regional VCE and ICSEA summaries; the shading and legend update.</a:t>
+            </a:r>
+          </a:p>
+          <a:p>
+            <a:pPr marL="342900" lvl="0" indent="-342900">
+              <a:buFont typeface="Arial" panose="020B0604020202020204" pitchFamily="34" charset="0"/>
+              <a:buChar char="•"/>
+            </a:pPr>
+            <a:r>
+              <a:rPr lang="zh-HK" altLang="zh-HK" sz="1200" dirty="0"/>
+              <a:t>Individual school symbols are not clickable.</a:t>
+            </a:r>
+          </a:p>
+          <a:p>
+            <a:pPr marL="342900" lvl="0" indent="-342900">
+              <a:buFont typeface="Arial" panose="020B0604020202020204" pitchFamily="34" charset="0"/>
+              <a:buChar char="•"/>
+            </a:pPr>
+            <a:r>
+              <a:rPr lang="zh-HK" altLang="zh-HK" sz="1200" dirty="0"/>
+              <a:t>Scroll down to explore student backgrounds.</a:t>
+            </a:r>
+          </a:p>
+          <a:p>
+            <a:pPr>
+              <a:buNone/>
+            </a:pPr>
+            <a:r>
+              <a:rPr lang="zh-HK" altLang="zh-HK" sz="1200" b="1" dirty="0"/>
+              <a:t>3. Background:</a:t>
+            </a:r>
+            <a:r>
+              <a:rPr lang="zh-HK" altLang="zh-HK" sz="1200" dirty="0"/>
+              <a:t> </a:t>
+            </a:r>
+            <a:endParaRPr lang="en-US" altLang="zh-HK" sz="1200" dirty="0"/>
+          </a:p>
+          <a:p>
+            <a:pPr marL="342900" lvl="0" indent="-342900">
+              <a:buFont typeface="Arial" panose="020B0604020202020204" pitchFamily="34" charset="0"/>
+              <a:buChar char="•"/>
+            </a:pPr>
+            <a:r>
+              <a:rPr lang="zh-HK" altLang="zh-HK" sz="1200" dirty="0"/>
+              <a:t>Select a school dot to highlight it and show its name.</a:t>
+            </a:r>
+          </a:p>
+          <a:p>
+            <a:pPr marL="342900" lvl="0" indent="-342900">
+              <a:buFont typeface="Arial" panose="020B0604020202020204" pitchFamily="34" charset="0"/>
+              <a:buChar char="•"/>
+            </a:pPr>
+            <a:r>
+              <a:rPr lang="zh-HK" altLang="zh-HK" sz="1200" dirty="0"/>
+              <a:t>Select </a:t>
+            </a:r>
+            <a:r>
+              <a:rPr lang="zh-HK" altLang="zh-HK" sz="1200" b="1" dirty="0"/>
+              <a:t>“See its three-year trend”</a:t>
+            </a:r>
+            <a:r>
+              <a:rPr lang="zh-HK" altLang="zh-HK" sz="1200" dirty="0"/>
+              <a:t> to reveal a small line chart.</a:t>
+            </a:r>
+          </a:p>
+          <a:p>
+            <a:pPr marL="342900" lvl="0" indent="-342900">
+              <a:buFont typeface="Arial" panose="020B0604020202020204" pitchFamily="34" charset="0"/>
+              <a:buChar char="•"/>
+            </a:pPr>
+            <a:r>
+              <a:rPr lang="zh-HK" altLang="zh-HK" sz="1200" dirty="0"/>
+              <a:t>Close the trend to return to the scatter plot.</a:t>
+            </a:r>
+          </a:p>
+          <a:p>
+            <a:pPr marL="342900" lvl="0" indent="-342900">
+              <a:buFont typeface="Arial" panose="020B0604020202020204" pitchFamily="34" charset="0"/>
+              <a:buChar char="•"/>
+            </a:pPr>
+            <a:r>
+              <a:rPr lang="zh-HK" altLang="zh-HK" sz="1200" dirty="0"/>
+              <a:t>Scroll down to learn about the four school profiles.</a:t>
+            </a:r>
+          </a:p>
+          <a:p>
+            <a:pPr>
+              <a:buNone/>
+            </a:pPr>
+            <a:r>
+              <a:rPr lang="zh-HK" altLang="zh-HK" sz="1200" b="1" dirty="0"/>
+              <a:t>4. Profiles:</a:t>
+            </a:r>
+            <a:r>
+              <a:rPr lang="zh-HK" altLang="zh-HK" sz="1200" dirty="0"/>
+              <a:t> </a:t>
+            </a:r>
+            <a:endParaRPr lang="en-US" altLang="zh-HK" sz="1200" dirty="0"/>
+          </a:p>
+          <a:p>
+            <a:pPr marL="342900" lvl="0" indent="-342900">
+              <a:buFont typeface="Arial" panose="020B0604020202020204" pitchFamily="34" charset="0"/>
+              <a:buChar char="•"/>
+            </a:pPr>
+            <a:r>
+              <a:rPr lang="zh-HK" altLang="zh-HK" sz="1200" dirty="0"/>
+              <a:t>Select a profile circle to reveal its explanation and an example school’s three-year trend.</a:t>
+            </a:r>
+          </a:p>
+          <a:p>
+            <a:pPr marL="342900" lvl="0" indent="-342900">
+              <a:buFont typeface="Arial" panose="020B0604020202020204" pitchFamily="34" charset="0"/>
+              <a:buChar char="•"/>
+            </a:pPr>
+            <a:r>
+              <a:rPr lang="zh-HK" altLang="zh-HK" sz="1200" dirty="0"/>
+              <a:t>Select </a:t>
+            </a:r>
+            <a:r>
+              <a:rPr lang="zh-HK" altLang="zh-HK" sz="1200" b="1" dirty="0"/>
+              <a:t>“Where are these schools?”</a:t>
+            </a:r>
+            <a:r>
+              <a:rPr lang="zh-HK" altLang="zh-HK" sz="1200" dirty="0"/>
+              <a:t> to animate its school dots onto the map.</a:t>
+            </a:r>
+          </a:p>
+          <a:p>
+            <a:pPr marL="342900" lvl="0" indent="-342900">
+              <a:buFont typeface="Arial" panose="020B0604020202020204" pitchFamily="34" charset="0"/>
+              <a:buChar char="•"/>
+            </a:pPr>
+            <a:r>
+              <a:rPr lang="zh-HK" altLang="zh-HK" sz="1200" dirty="0"/>
+              <a:t>Movement trails disappear after the dots arrive. Individual markers are not clickable.</a:t>
+            </a:r>
+          </a:p>
+          <a:p>
+            <a:pPr marL="342900" lvl="0" indent="-342900">
+              <a:buFont typeface="Arial" panose="020B0604020202020204" pitchFamily="34" charset="0"/>
+              <a:buChar char="•"/>
+            </a:pPr>
+            <a:r>
+              <a:rPr lang="zh-HK" altLang="zh-HK" sz="1200" dirty="0"/>
+              <a:t>Select </a:t>
+            </a:r>
+            <a:r>
+              <a:rPr lang="zh-HK" altLang="zh-HK" sz="1200" b="1" dirty="0"/>
+              <a:t>“Back to profiles”</a:t>
+            </a:r>
+            <a:r>
+              <a:rPr lang="zh-HK" altLang="zh-HK" sz="1200" dirty="0"/>
+              <a:t> to return, or scroll down to explore school zones.</a:t>
+            </a:r>
+          </a:p>
+          <a:p>
+            <a:pPr>
+              <a:buNone/>
+            </a:pPr>
+            <a:r>
+              <a:rPr lang="zh-HK" altLang="zh-HK" sz="1200" b="1" dirty="0"/>
+              <a:t>5. School zones:</a:t>
+            </a:r>
+            <a:r>
+              <a:rPr lang="zh-HK" altLang="zh-HK" sz="1200" dirty="0"/>
+              <a:t> </a:t>
+            </a:r>
+            <a:endParaRPr lang="en-US" altLang="zh-HK" sz="1200" dirty="0"/>
+          </a:p>
+          <a:p>
+            <a:pPr marL="342900" lvl="0" indent="-342900">
+              <a:buFont typeface="Arial" panose="020B0604020202020204" pitchFamily="34" charset="0"/>
+              <a:buChar char="•"/>
+            </a:pPr>
+            <a:r>
+              <a:rPr lang="zh-HK" altLang="zh-HK" sz="1200" dirty="0"/>
+              <a:t>Move the results slider to highlight zones within the selected range.</a:t>
+            </a:r>
+          </a:p>
+          <a:p>
+            <a:pPr marL="342900" lvl="0" indent="-342900">
+              <a:buFont typeface="Arial" panose="020B0604020202020204" pitchFamily="34" charset="0"/>
+              <a:buChar char="•"/>
+            </a:pPr>
+            <a:r>
+              <a:rPr lang="zh-HK" altLang="zh-HK" sz="1200" dirty="0"/>
+              <a:t>Other zones fade but remain visible for geographical context.</a:t>
+            </a:r>
+          </a:p>
+          <a:p>
+            <a:pPr marL="342900" lvl="0" indent="-342900">
+              <a:buFont typeface="Arial" panose="020B0604020202020204" pitchFamily="34" charset="0"/>
+              <a:buChar char="•"/>
+            </a:pPr>
+            <a:r>
+              <a:rPr lang="zh-HK" altLang="zh-HK" sz="1200" dirty="0"/>
+              <a:t>Select a zone to open a white information card showing its associated school’s results and year, ICSEA, three-year change and available course information.</a:t>
+            </a:r>
+          </a:p>
+          <a:p>
+            <a:pPr marL="342900" lvl="0" indent="-342900">
+              <a:buFont typeface="Arial" panose="020B0604020202020204" pitchFamily="34" charset="0"/>
+              <a:buChar char="•"/>
+            </a:pPr>
+            <a:r>
+              <a:rPr lang="zh-HK" altLang="zh-HK" sz="1200" dirty="0"/>
+              <a:t>The card includes the data source and zone reference year.</a:t>
+            </a:r>
+          </a:p>
+          <a:p>
+            <a:pPr marL="342900" lvl="0" indent="-342900">
+              <a:buFont typeface="Arial" panose="020B0604020202020204" pitchFamily="34" charset="0"/>
+              <a:buChar char="•"/>
+            </a:pPr>
+            <a:r>
+              <a:rPr lang="zh-HK" altLang="zh-HK" sz="1200" dirty="0"/>
+              <a:t>Close the card to return to the map.</a:t>
+            </a:r>
+          </a:p>
+          <a:p>
+            <a:pPr marL="342900" lvl="0" indent="-342900">
+              <a:buFont typeface="Arial" panose="020B0604020202020204" pitchFamily="34" charset="0"/>
+              <a:buChar char="•"/>
+            </a:pPr>
+            <a:r>
+              <a:rPr lang="zh-HK" altLang="zh-HK" sz="1200" dirty="0"/>
+              <a:t>Scroll down to the final takeaway: consider background, trends, courses and entry requirements before moving.</a:t>
+            </a:r>
+          </a:p>
+        </p:txBody>
+      </p:sp>
+      <p:sp>
+        <p:nvSpPr>
+          <p:cNvPr id="90" name="文字方塊 89">
+            <a:extLst>
+              <a:ext uri="{FF2B5EF4-FFF2-40B4-BE49-F238E27FC236}">
+                <a16:creationId xmlns:a16="http://schemas.microsoft.com/office/drawing/2014/main" id="{C18B7681-FF85-D6F3-0B76-1A2BB59C7B0A}"/>
+              </a:ext>
+            </a:extLst>
+          </p:cNvPr>
+          <p:cNvSpPr txBox="1"/>
+          <p:nvPr/>
+        </p:nvSpPr>
+        <p:spPr>
+          <a:xfrm>
+            <a:off x="10809232" y="612554"/>
+            <a:ext cx="1523174" cy="369332"/>
+          </a:xfrm>
+          <a:prstGeom prst="rect">
+            <a:avLst/>
+          </a:prstGeom>
+          <a:noFill/>
+        </p:spPr>
+        <p:txBody>
+          <a:bodyPr wrap="none" rtlCol="0">
+            <a:spAutoFit/>
+          </a:bodyPr>
+          <a:lstStyle/>
+          <a:p>
+            <a:r>
+              <a:rPr lang="en-US" altLang="zh-HK" dirty="0"/>
+              <a:t>Sin Ping CHAN</a:t>
+            </a:r>
+            <a:endParaRPr lang="zh-HK" altLang="en-US" dirty="0"/>
+          </a:p>
+        </p:txBody>
+      </p:sp>
+      <p:sp>
+        <p:nvSpPr>
+          <p:cNvPr id="92" name="文字方塊 91">
+            <a:extLst>
+              <a:ext uri="{FF2B5EF4-FFF2-40B4-BE49-F238E27FC236}">
+                <a16:creationId xmlns:a16="http://schemas.microsoft.com/office/drawing/2014/main" id="{ECAEA615-74F3-A6FB-3C15-85E3FEB144E5}"/>
+              </a:ext>
+            </a:extLst>
+          </p:cNvPr>
+          <p:cNvSpPr txBox="1"/>
+          <p:nvPr/>
+        </p:nvSpPr>
+        <p:spPr>
+          <a:xfrm>
+            <a:off x="14192148" y="623600"/>
+            <a:ext cx="1300356" cy="369332"/>
+          </a:xfrm>
+          <a:prstGeom prst="rect">
+            <a:avLst/>
+          </a:prstGeom>
+          <a:noFill/>
+        </p:spPr>
+        <p:txBody>
+          <a:bodyPr wrap="none" rtlCol="0">
+            <a:spAutoFit/>
+          </a:bodyPr>
+          <a:lstStyle/>
+          <a:p>
+            <a:r>
+              <a:rPr lang="en-US" altLang="zh-HK" dirty="0"/>
+              <a:t>08/10/2026</a:t>
+            </a:r>
+            <a:endParaRPr lang="zh-HK" altLang="en-US" dirty="0"/>
+          </a:p>
+        </p:txBody>
+      </p:sp>
+      <p:sp>
+        <p:nvSpPr>
+          <p:cNvPr id="94" name="文字方塊 93">
+            <a:extLst>
+              <a:ext uri="{FF2B5EF4-FFF2-40B4-BE49-F238E27FC236}">
+                <a16:creationId xmlns:a16="http://schemas.microsoft.com/office/drawing/2014/main" id="{D2C00E28-024C-0B7B-AB39-8CBCEDB25917}"/>
+              </a:ext>
+            </a:extLst>
+          </p:cNvPr>
+          <p:cNvSpPr txBox="1"/>
+          <p:nvPr/>
+        </p:nvSpPr>
+        <p:spPr>
+          <a:xfrm>
+            <a:off x="17330721" y="604168"/>
+            <a:ext cx="301686" cy="369332"/>
+          </a:xfrm>
+          <a:prstGeom prst="rect">
+            <a:avLst/>
+          </a:prstGeom>
+          <a:noFill/>
+        </p:spPr>
+        <p:txBody>
+          <a:bodyPr wrap="none" rtlCol="0">
+            <a:spAutoFit/>
+          </a:bodyPr>
+          <a:lstStyle/>
+          <a:p>
+            <a:r>
+              <a:rPr lang="en-US" altLang="zh-HK" dirty="0"/>
+              <a:t>2</a:t>
+            </a:r>
+            <a:endParaRPr lang="zh-HK" altLang="en-US" dirty="0"/>
+          </a:p>
+        </p:txBody>
+      </p:sp>
+      <p:sp>
+        <p:nvSpPr>
+          <p:cNvPr id="96" name="文字方塊 95">
+            <a:extLst>
+              <a:ext uri="{FF2B5EF4-FFF2-40B4-BE49-F238E27FC236}">
+                <a16:creationId xmlns:a16="http://schemas.microsoft.com/office/drawing/2014/main" id="{B7064CBC-816F-A11A-38D0-91EBC0ED214E}"/>
+              </a:ext>
+            </a:extLst>
+          </p:cNvPr>
+          <p:cNvSpPr txBox="1"/>
+          <p:nvPr/>
+        </p:nvSpPr>
+        <p:spPr>
+          <a:xfrm>
+            <a:off x="10404273" y="1174214"/>
+            <a:ext cx="10064750" cy="369332"/>
+          </a:xfrm>
+          <a:prstGeom prst="rect">
+            <a:avLst/>
+          </a:prstGeom>
+          <a:noFill/>
+        </p:spPr>
+        <p:txBody>
+          <a:bodyPr wrap="square">
+            <a:spAutoFit/>
+          </a:bodyPr>
+          <a:lstStyle/>
+          <a:p>
+            <a:r>
+              <a:rPr lang="zh-HK" altLang="zh-HK" dirty="0"/>
+              <a:t>Design a scrolling story for parents considering a move for a school zone.</a:t>
+            </a:r>
+            <a:endParaRPr lang="zh-HK" altLang="en-US" dirty="0"/>
+          </a:p>
+        </p:txBody>
+      </p:sp>
+      <p:sp>
+        <p:nvSpPr>
+          <p:cNvPr id="98" name="文字方塊 97">
+            <a:extLst>
+              <a:ext uri="{FF2B5EF4-FFF2-40B4-BE49-F238E27FC236}">
+                <a16:creationId xmlns:a16="http://schemas.microsoft.com/office/drawing/2014/main" id="{72727F4D-7C9F-3A11-7CD0-AD13A9904767}"/>
+              </a:ext>
+            </a:extLst>
+          </p:cNvPr>
+          <p:cNvSpPr txBox="1"/>
+          <p:nvPr/>
+        </p:nvSpPr>
+        <p:spPr>
+          <a:xfrm>
+            <a:off x="1086121" y="98758"/>
+            <a:ext cx="10236200" cy="369332"/>
+          </a:xfrm>
+          <a:prstGeom prst="rect">
+            <a:avLst/>
+          </a:prstGeom>
+          <a:noFill/>
+        </p:spPr>
+        <p:txBody>
+          <a:bodyPr wrap="square">
+            <a:spAutoFit/>
+          </a:bodyPr>
+          <a:lstStyle/>
+          <a:p>
+            <a:r>
+              <a:rPr lang="zh-HK" altLang="zh-HK" b="1" dirty="0">
+                <a:highlight>
+                  <a:srgbClr val="FFFF00"/>
+                </a:highlight>
+              </a:rPr>
+              <a:t>Genre:</a:t>
+            </a:r>
+            <a:r>
+              <a:rPr lang="zh-HK" altLang="zh-HK" dirty="0">
+                <a:highlight>
+                  <a:srgbClr val="FFFF00"/>
+                </a:highlight>
+              </a:rPr>
+              <a:t> Magazine + annotated charts | Guided story with limited interaction</a:t>
+            </a:r>
+            <a:endParaRPr lang="zh-HK" altLang="en-US" dirty="0">
+              <a:highlight>
+                <a:srgbClr val="FFFF00"/>
+              </a:highlight>
+            </a:endParaRPr>
+          </a:p>
+        </p:txBody>
+      </p:sp>
+      <p:sp>
+        <p:nvSpPr>
+          <p:cNvPr id="101" name="文字方塊 100">
+            <a:extLst>
+              <a:ext uri="{FF2B5EF4-FFF2-40B4-BE49-F238E27FC236}">
+                <a16:creationId xmlns:a16="http://schemas.microsoft.com/office/drawing/2014/main" id="{A4889F77-776D-D02A-ABBD-B1BC61F928AE}"/>
+              </a:ext>
+            </a:extLst>
+          </p:cNvPr>
+          <p:cNvSpPr txBox="1"/>
+          <p:nvPr/>
+        </p:nvSpPr>
+        <p:spPr>
+          <a:xfrm>
+            <a:off x="377954" y="4009586"/>
+            <a:ext cx="6074084" cy="2677656"/>
+          </a:xfrm>
+          <a:prstGeom prst="rect">
+            <a:avLst/>
+          </a:prstGeom>
+          <a:noFill/>
+        </p:spPr>
+        <p:txBody>
+          <a:bodyPr wrap="square">
+            <a:spAutoFit/>
+          </a:bodyPr>
+          <a:lstStyle/>
+          <a:p>
+            <a:pPr marL="342900" indent="-342900">
+              <a:buFont typeface="+mj-lt"/>
+              <a:buAutoNum type="arabicPeriod"/>
+            </a:pPr>
+            <a:r>
+              <a:rPr lang="zh-HK" altLang="zh-HK" sz="1400" b="1" dirty="0"/>
+              <a:t>Results — Sector distributions</a:t>
+            </a:r>
+            <a:r>
+              <a:rPr lang="en-US" altLang="zh-HK" sz="1400" b="1" dirty="0"/>
+              <a:t> </a:t>
+            </a:r>
+            <a:r>
+              <a:rPr lang="zh-HK" altLang="zh-HK" sz="1400" dirty="0"/>
+              <a:t>#1</a:t>
+            </a:r>
+            <a:br>
+              <a:rPr lang="en-US" altLang="zh-HK" sz="1400" b="1" dirty="0"/>
+            </a:br>
+            <a:r>
+              <a:rPr lang="zh-HK" altLang="zh-HK" sz="1400" dirty="0"/>
+              <a:t>Shows how results vary within sectors. Government schools also have a wide range of results.</a:t>
+            </a:r>
+            <a:r>
+              <a:rPr lang="en-US" altLang="zh-HK" sz="1400" b="1" dirty="0"/>
+              <a:t> </a:t>
+            </a:r>
+          </a:p>
+          <a:p>
+            <a:pPr marL="342900" indent="-342900">
+              <a:buFont typeface="+mj-lt"/>
+              <a:buAutoNum type="arabicPeriod"/>
+            </a:pPr>
+            <a:r>
+              <a:rPr lang="zh-HK" altLang="zh-HK" sz="1400" b="1" dirty="0"/>
+              <a:t>Location — Regional school options</a:t>
+            </a:r>
+            <a:r>
+              <a:rPr lang="en-US" altLang="zh-HK" sz="1400" b="1" dirty="0"/>
+              <a:t>  </a:t>
+            </a:r>
+            <a:r>
+              <a:rPr lang="zh-HK" altLang="zh-HK" sz="1400" dirty="0"/>
+              <a:t>#5 + #6</a:t>
+            </a:r>
+            <a:br>
+              <a:rPr lang="en-US" altLang="zh-HK" sz="1400" dirty="0"/>
+            </a:br>
+            <a:r>
+              <a:rPr lang="zh-HK" altLang="zh-HK" sz="1400" dirty="0"/>
+              <a:t>Shows school locations and the mix of school sectors within each region.</a:t>
+            </a:r>
+          </a:p>
+          <a:p>
+            <a:pPr marL="342900" lvl="0" indent="-342900">
+              <a:buFont typeface="+mj-lt"/>
+              <a:buAutoNum type="arabicPeriod"/>
+            </a:pPr>
+            <a:r>
+              <a:rPr lang="zh-HK" altLang="zh-HK" sz="1400" b="1" dirty="0"/>
+              <a:t>Background — ICSEA and results</a:t>
+            </a:r>
+            <a:r>
+              <a:rPr lang="en-US" altLang="zh-HK" sz="1400" b="1" dirty="0"/>
+              <a:t>  </a:t>
+            </a:r>
+            <a:r>
+              <a:rPr lang="zh-HK" altLang="zh-HK" sz="1400" dirty="0"/>
+              <a:t>#1 + #2</a:t>
+            </a:r>
+            <a:br>
+              <a:rPr lang="en-US" altLang="zh-HK" sz="1400" dirty="0"/>
+            </a:br>
+            <a:r>
+              <a:rPr lang="zh-HK" altLang="zh-HK" sz="1400" dirty="0"/>
+              <a:t>Shows the relationship between ICSEA and school results.</a:t>
+            </a:r>
+          </a:p>
+          <a:p>
+            <a:pPr marL="342900" indent="-342900">
+              <a:buFont typeface="+mj-lt"/>
+              <a:buAutoNum type="arabicPeriod"/>
+            </a:pPr>
+            <a:r>
+              <a:rPr lang="zh-HK" altLang="zh-HK" sz="1400" b="1" dirty="0"/>
+              <a:t>Profiles — Trends and locations</a:t>
+            </a:r>
+            <a:r>
+              <a:rPr lang="en-US" altLang="zh-HK" sz="1400" b="1" dirty="0"/>
+              <a:t>  </a:t>
+            </a:r>
+            <a:r>
+              <a:rPr lang="zh-HK" altLang="zh-HK" sz="1400" dirty="0"/>
+              <a:t>#7 + #2 + #5</a:t>
+            </a:r>
+            <a:br>
+              <a:rPr lang="en-US" altLang="zh-HK" sz="1400" dirty="0"/>
+            </a:br>
+            <a:r>
+              <a:rPr lang="zh-HK" altLang="zh-HK" sz="1400" dirty="0"/>
+              <a:t>Explains </a:t>
+            </a:r>
+            <a:r>
+              <a:rPr lang="en-US" altLang="zh-HK" sz="1400" dirty="0"/>
+              <a:t>4 </a:t>
+            </a:r>
+            <a:r>
+              <a:rPr lang="zh-HK" altLang="zh-HK" sz="1400" dirty="0"/>
+              <a:t>school profiles and shows where their schools are located.</a:t>
+            </a:r>
+          </a:p>
+          <a:p>
+            <a:pPr marL="342900" indent="-342900">
+              <a:buFont typeface="+mj-lt"/>
+              <a:buAutoNum type="arabicPeriod"/>
+            </a:pPr>
+            <a:r>
+              <a:rPr lang="zh-HK" altLang="zh-HK" sz="1400" b="1" dirty="0"/>
+              <a:t>School zones — Details before moving</a:t>
+            </a:r>
+            <a:r>
+              <a:rPr lang="en-US" altLang="zh-HK" sz="1400" b="1" dirty="0"/>
+              <a:t>  </a:t>
+            </a:r>
+            <a:r>
+              <a:rPr lang="zh-HK" altLang="zh-HK" sz="1400" dirty="0"/>
+              <a:t>#6 + slider + card</a:t>
+            </a:r>
+            <a:br>
+              <a:rPr lang="en-US" altLang="zh-HK" sz="1400" dirty="0"/>
+            </a:br>
+            <a:r>
+              <a:rPr lang="zh-HK" altLang="zh-HK" sz="1400" dirty="0"/>
+              <a:t>Helps parents read school-zone details beyond a single score.</a:t>
+            </a:r>
+          </a:p>
+          <a:p>
+            <a:pPr marL="342900" lvl="0" indent="-342900">
+              <a:buFont typeface="+mj-lt"/>
+              <a:buAutoNum type="arabicPeriod"/>
+            </a:pPr>
+            <a:endParaRPr lang="zh-HK" altLang="zh-HK" sz="1400" dirty="0"/>
+          </a:p>
+        </p:txBody>
+      </p:sp>
+      <p:sp>
+        <p:nvSpPr>
+          <p:cNvPr id="105" name="文字方塊 104">
+            <a:extLst>
+              <a:ext uri="{FF2B5EF4-FFF2-40B4-BE49-F238E27FC236}">
+                <a16:creationId xmlns:a16="http://schemas.microsoft.com/office/drawing/2014/main" id="{F76D4820-A477-E296-2080-75B220EF15DD}"/>
+              </a:ext>
+            </a:extLst>
+          </p:cNvPr>
+          <p:cNvSpPr txBox="1"/>
+          <p:nvPr/>
+        </p:nvSpPr>
+        <p:spPr>
+          <a:xfrm>
+            <a:off x="665820" y="2755301"/>
+            <a:ext cx="2686980" cy="369332"/>
+          </a:xfrm>
+          <a:prstGeom prst="rect">
+            <a:avLst/>
+          </a:prstGeom>
+          <a:noFill/>
+        </p:spPr>
+        <p:txBody>
+          <a:bodyPr wrap="square">
+            <a:spAutoFit/>
+          </a:bodyPr>
+          <a:lstStyle/>
+          <a:p>
+            <a:r>
+              <a:rPr lang="zh-HK" altLang="zh-HK" dirty="0"/>
+              <a:t>One main visual at a time</a:t>
+            </a:r>
+            <a:endParaRPr lang="zh-HK" altLang="en-US" dirty="0"/>
+          </a:p>
+        </p:txBody>
+      </p:sp>
+      <p:sp>
+        <p:nvSpPr>
+          <p:cNvPr id="109" name="文字方塊 108">
+            <a:extLst>
+              <a:ext uri="{FF2B5EF4-FFF2-40B4-BE49-F238E27FC236}">
+                <a16:creationId xmlns:a16="http://schemas.microsoft.com/office/drawing/2014/main" id="{4EA784F9-8386-5491-1BCD-83307AAA283A}"/>
+              </a:ext>
+            </a:extLst>
+          </p:cNvPr>
+          <p:cNvSpPr txBox="1"/>
+          <p:nvPr/>
+        </p:nvSpPr>
+        <p:spPr>
+          <a:xfrm>
+            <a:off x="5979405" y="1254151"/>
+            <a:ext cx="301686" cy="369332"/>
+          </a:xfrm>
+          <a:prstGeom prst="rect">
+            <a:avLst/>
+          </a:prstGeom>
+          <a:noFill/>
+        </p:spPr>
+        <p:txBody>
+          <a:bodyPr wrap="none" rtlCol="0">
+            <a:spAutoFit/>
+          </a:bodyPr>
+          <a:lstStyle/>
+          <a:p>
+            <a:r>
+              <a:rPr lang="en-US" altLang="zh-HK" dirty="0">
+                <a:highlight>
+                  <a:srgbClr val="FFFF00"/>
+                </a:highlight>
+              </a:rPr>
+              <a:t>2</a:t>
+            </a:r>
+            <a:endParaRPr lang="zh-HK" altLang="en-US" dirty="0">
+              <a:highlight>
+                <a:srgbClr val="FFFF00"/>
+              </a:highlight>
+            </a:endParaRPr>
+          </a:p>
+        </p:txBody>
+      </p:sp>
+      <p:sp>
+        <p:nvSpPr>
+          <p:cNvPr id="111" name="文字方塊 110">
+            <a:extLst>
+              <a:ext uri="{FF2B5EF4-FFF2-40B4-BE49-F238E27FC236}">
+                <a16:creationId xmlns:a16="http://schemas.microsoft.com/office/drawing/2014/main" id="{4C55626D-02CE-A0BE-AF14-6C73AAA34681}"/>
+              </a:ext>
+            </a:extLst>
+          </p:cNvPr>
+          <p:cNvSpPr txBox="1"/>
+          <p:nvPr/>
+        </p:nvSpPr>
+        <p:spPr>
+          <a:xfrm>
+            <a:off x="7388646" y="441369"/>
+            <a:ext cx="301686" cy="369332"/>
+          </a:xfrm>
+          <a:prstGeom prst="rect">
+            <a:avLst/>
+          </a:prstGeom>
+          <a:noFill/>
+        </p:spPr>
+        <p:txBody>
+          <a:bodyPr wrap="none" rtlCol="0">
+            <a:spAutoFit/>
+          </a:bodyPr>
+          <a:lstStyle/>
+          <a:p>
+            <a:r>
+              <a:rPr lang="en-US" altLang="zh-HK" dirty="0">
+                <a:highlight>
+                  <a:srgbClr val="FFFF00"/>
+                </a:highlight>
+              </a:rPr>
+              <a:t>1</a:t>
+            </a:r>
+            <a:endParaRPr lang="zh-HK" altLang="en-US" dirty="0">
+              <a:highlight>
+                <a:srgbClr val="FFFF00"/>
+              </a:highlight>
+            </a:endParaRPr>
+          </a:p>
+        </p:txBody>
+      </p:sp>
+      <p:sp>
+        <p:nvSpPr>
+          <p:cNvPr id="113" name="文字方塊 112">
+            <a:extLst>
+              <a:ext uri="{FF2B5EF4-FFF2-40B4-BE49-F238E27FC236}">
+                <a16:creationId xmlns:a16="http://schemas.microsoft.com/office/drawing/2014/main" id="{B83A8C7B-78C6-0412-C643-7CDCD3FDF8F5}"/>
+              </a:ext>
+            </a:extLst>
+          </p:cNvPr>
+          <p:cNvSpPr txBox="1"/>
+          <p:nvPr/>
+        </p:nvSpPr>
+        <p:spPr>
+          <a:xfrm>
+            <a:off x="7564096" y="2689736"/>
+            <a:ext cx="301686" cy="369332"/>
+          </a:xfrm>
+          <a:prstGeom prst="rect">
+            <a:avLst/>
+          </a:prstGeom>
+          <a:noFill/>
+        </p:spPr>
+        <p:txBody>
+          <a:bodyPr wrap="none" rtlCol="0">
+            <a:spAutoFit/>
+          </a:bodyPr>
+          <a:lstStyle/>
+          <a:p>
+            <a:r>
+              <a:rPr lang="en-US" altLang="zh-HK" dirty="0">
+                <a:highlight>
+                  <a:srgbClr val="FFFF00"/>
+                </a:highlight>
+              </a:rPr>
+              <a:t>3</a:t>
+            </a:r>
+            <a:endParaRPr lang="zh-HK" altLang="en-US" dirty="0">
+              <a:highlight>
+                <a:srgbClr val="FFFF00"/>
+              </a:highlight>
+            </a:endParaRPr>
+          </a:p>
+        </p:txBody>
+      </p:sp>
+      <p:sp>
+        <p:nvSpPr>
+          <p:cNvPr id="115" name="文字方塊 114">
+            <a:extLst>
+              <a:ext uri="{FF2B5EF4-FFF2-40B4-BE49-F238E27FC236}">
+                <a16:creationId xmlns:a16="http://schemas.microsoft.com/office/drawing/2014/main" id="{16219C46-2FA1-30A6-BD82-E1ED1CAFDDFF}"/>
+              </a:ext>
+            </a:extLst>
+          </p:cNvPr>
+          <p:cNvSpPr txBox="1"/>
+          <p:nvPr/>
+        </p:nvSpPr>
+        <p:spPr>
+          <a:xfrm>
+            <a:off x="6535444" y="3864160"/>
+            <a:ext cx="301686" cy="369332"/>
+          </a:xfrm>
+          <a:prstGeom prst="rect">
+            <a:avLst/>
+          </a:prstGeom>
+          <a:noFill/>
+        </p:spPr>
+        <p:txBody>
+          <a:bodyPr wrap="none" rtlCol="0">
+            <a:spAutoFit/>
+          </a:bodyPr>
+          <a:lstStyle/>
+          <a:p>
+            <a:r>
+              <a:rPr lang="en-US" altLang="zh-HK" dirty="0">
+                <a:highlight>
+                  <a:srgbClr val="FFFF00"/>
+                </a:highlight>
+              </a:rPr>
+              <a:t>4</a:t>
+            </a:r>
+            <a:endParaRPr lang="zh-HK" altLang="en-US" dirty="0">
+              <a:highlight>
+                <a:srgbClr val="FFFF00"/>
+              </a:highlight>
+            </a:endParaRPr>
+          </a:p>
+        </p:txBody>
+      </p:sp>
+      <p:sp>
+        <p:nvSpPr>
+          <p:cNvPr id="117" name="文字方塊 116">
+            <a:extLst>
+              <a:ext uri="{FF2B5EF4-FFF2-40B4-BE49-F238E27FC236}">
+                <a16:creationId xmlns:a16="http://schemas.microsoft.com/office/drawing/2014/main" id="{F1EAB190-A4FC-C8E0-DA2E-E4AC451841B9}"/>
+              </a:ext>
+            </a:extLst>
+          </p:cNvPr>
+          <p:cNvSpPr txBox="1"/>
+          <p:nvPr/>
+        </p:nvSpPr>
+        <p:spPr>
+          <a:xfrm>
+            <a:off x="6719396" y="5328060"/>
+            <a:ext cx="301686" cy="369332"/>
+          </a:xfrm>
+          <a:prstGeom prst="rect">
+            <a:avLst/>
+          </a:prstGeom>
+          <a:noFill/>
+        </p:spPr>
+        <p:txBody>
+          <a:bodyPr wrap="none" rtlCol="0">
+            <a:spAutoFit/>
+          </a:bodyPr>
+          <a:lstStyle/>
+          <a:p>
+            <a:r>
+              <a:rPr lang="en-US" altLang="zh-HK" dirty="0">
+                <a:highlight>
+                  <a:srgbClr val="FFFF00"/>
+                </a:highlight>
+              </a:rPr>
+              <a:t>5</a:t>
+            </a:r>
+            <a:endParaRPr lang="zh-HK" altLang="en-US" dirty="0">
+              <a:highlight>
+                <a:srgbClr val="FFFF00"/>
+              </a:highlight>
+            </a:endParaRPr>
+          </a:p>
+        </p:txBody>
+      </p:sp>
+      <p:sp>
+        <p:nvSpPr>
+          <p:cNvPr id="119" name="文字方塊 118">
+            <a:extLst>
+              <a:ext uri="{FF2B5EF4-FFF2-40B4-BE49-F238E27FC236}">
+                <a16:creationId xmlns:a16="http://schemas.microsoft.com/office/drawing/2014/main" id="{15D419DE-6486-C490-B0B8-85B7F4903C58}"/>
+              </a:ext>
+            </a:extLst>
+          </p:cNvPr>
+          <p:cNvSpPr txBox="1"/>
+          <p:nvPr/>
+        </p:nvSpPr>
+        <p:spPr>
+          <a:xfrm>
+            <a:off x="884733" y="6706647"/>
+            <a:ext cx="7561607" cy="369332"/>
+          </a:xfrm>
+          <a:prstGeom prst="rect">
+            <a:avLst/>
+          </a:prstGeom>
+          <a:noFill/>
+        </p:spPr>
+        <p:txBody>
+          <a:bodyPr wrap="square">
+            <a:spAutoFit/>
+          </a:bodyPr>
+          <a:lstStyle/>
+          <a:p>
+            <a:pPr>
+              <a:buNone/>
+            </a:pPr>
+            <a:r>
+              <a:rPr lang="zh-HK" altLang="zh-HK" b="1" dirty="0">
+                <a:highlight>
+                  <a:srgbClr val="FFFF00"/>
+                </a:highlight>
+              </a:rPr>
+              <a:t>Scene 4 interaction: select, explain, locate</a:t>
+            </a:r>
+            <a:endParaRPr lang="zh-HK" altLang="zh-HK" dirty="0">
+              <a:highlight>
+                <a:srgbClr val="FFFF00"/>
+              </a:highlight>
+            </a:endParaRPr>
+          </a:p>
+        </p:txBody>
+      </p:sp>
+      <p:sp>
+        <p:nvSpPr>
+          <p:cNvPr id="121" name="文字方塊 120">
+            <a:extLst>
+              <a:ext uri="{FF2B5EF4-FFF2-40B4-BE49-F238E27FC236}">
+                <a16:creationId xmlns:a16="http://schemas.microsoft.com/office/drawing/2014/main" id="{309C17DD-E402-7346-4962-722DE4C6AEED}"/>
+              </a:ext>
+            </a:extLst>
+          </p:cNvPr>
+          <p:cNvSpPr txBox="1"/>
+          <p:nvPr/>
+        </p:nvSpPr>
+        <p:spPr>
+          <a:xfrm>
+            <a:off x="9889810" y="7365754"/>
+            <a:ext cx="8209550" cy="2677656"/>
+          </a:xfrm>
+          <a:prstGeom prst="rect">
+            <a:avLst/>
+          </a:prstGeom>
+          <a:noFill/>
+        </p:spPr>
+        <p:txBody>
+          <a:bodyPr wrap="square">
+            <a:spAutoFit/>
+          </a:bodyPr>
+          <a:lstStyle/>
+          <a:p>
+            <a:pPr>
+              <a:buNone/>
+            </a:pPr>
+            <a:r>
+              <a:rPr lang="zh-HK" altLang="zh-HK" sz="1400" b="1" dirty="0"/>
+              <a:t>Strengths</a:t>
+            </a:r>
+            <a:endParaRPr lang="zh-HK" altLang="zh-HK" sz="1400" dirty="0"/>
+          </a:p>
+          <a:p>
+            <a:pPr marL="342900" lvl="0" indent="-342900">
+              <a:buFont typeface="Arial" panose="020B0604020202020204" pitchFamily="34" charset="0"/>
+              <a:buChar char="•"/>
+            </a:pPr>
+            <a:r>
+              <a:rPr lang="zh-HK" altLang="zh-HK" sz="1400" dirty="0"/>
+              <a:t>One focal visual reduces clutter.</a:t>
+            </a:r>
+          </a:p>
+          <a:p>
+            <a:pPr marL="342900" lvl="0" indent="-342900">
+              <a:buFont typeface="Arial" panose="020B0604020202020204" pitchFamily="34" charset="0"/>
+              <a:buChar char="•"/>
+            </a:pPr>
+            <a:r>
+              <a:rPr lang="zh-HK" altLang="zh-HK" sz="1400" dirty="0"/>
+              <a:t>A fixed sequence connects the story.</a:t>
+            </a:r>
+          </a:p>
+          <a:p>
+            <a:pPr marL="342900" lvl="0" indent="-342900">
+              <a:buFont typeface="Arial" panose="020B0604020202020204" pitchFamily="34" charset="0"/>
+              <a:buChar char="•"/>
+            </a:pPr>
+            <a:r>
+              <a:rPr lang="zh-HK" altLang="zh-HK" sz="1400" dirty="0"/>
+              <a:t>Short explanations support parents.</a:t>
+            </a:r>
+          </a:p>
+          <a:p>
+            <a:pPr>
+              <a:buNone/>
+            </a:pPr>
+            <a:r>
+              <a:rPr lang="zh-HK" altLang="zh-HK" sz="1400" b="1" dirty="0"/>
+              <a:t>Trade-offs</a:t>
+            </a:r>
+            <a:endParaRPr lang="zh-HK" altLang="zh-HK" sz="1400" dirty="0"/>
+          </a:p>
+          <a:p>
+            <a:pPr marL="342900" lvl="0" indent="-342900">
+              <a:buFont typeface="Arial" panose="020B0604020202020204" pitchFamily="34" charset="0"/>
+              <a:buChar char="•"/>
+            </a:pPr>
+            <a:r>
+              <a:rPr lang="zh-HK" altLang="zh-HK" sz="1400" dirty="0"/>
+              <a:t>Long scrolling needs progress cues.</a:t>
+            </a:r>
+          </a:p>
+          <a:p>
+            <a:pPr marL="342900" lvl="0" indent="-342900">
+              <a:buFont typeface="Arial" panose="020B0604020202020204" pitchFamily="34" charset="0"/>
+              <a:buChar char="•"/>
+            </a:pPr>
+            <a:r>
+              <a:rPr lang="zh-HK" altLang="zh-HK" sz="1400" dirty="0"/>
+              <a:t>Animation needs a static alternative.</a:t>
+            </a:r>
+          </a:p>
+          <a:p>
+            <a:pPr>
+              <a:buNone/>
+            </a:pPr>
+            <a:r>
+              <a:rPr lang="zh-HK" altLang="zh-HK" sz="1400" b="1" dirty="0"/>
+              <a:t>Design notes</a:t>
+            </a:r>
+            <a:endParaRPr lang="zh-HK" altLang="zh-HK" sz="1400" dirty="0"/>
+          </a:p>
+          <a:p>
+            <a:pPr marL="342900" lvl="0" indent="-342900">
+              <a:buFont typeface="Arial" panose="020B0604020202020204" pitchFamily="34" charset="0"/>
+              <a:buChar char="•"/>
+            </a:pPr>
+            <a:r>
+              <a:rPr lang="zh-HK" altLang="zh-HK" sz="1400" dirty="0"/>
+              <a:t>Keep axes and colour meanings clear.</a:t>
+            </a:r>
+          </a:p>
+          <a:p>
+            <a:pPr marL="342900" lvl="0" indent="-342900">
+              <a:buFont typeface="Arial" panose="020B0604020202020204" pitchFamily="34" charset="0"/>
+              <a:buChar char="•"/>
+            </a:pPr>
+            <a:r>
+              <a:rPr lang="zh-HK" altLang="zh-HK" sz="1400" dirty="0"/>
+              <a:t>Mark selective status separately from sector.</a:t>
+            </a:r>
+          </a:p>
+          <a:p>
+            <a:pPr marL="342900" lvl="0" indent="-342900">
+              <a:buFont typeface="Arial" panose="020B0604020202020204" pitchFamily="34" charset="0"/>
+              <a:buChar char="•"/>
+            </a:pPr>
+            <a:r>
+              <a:rPr lang="zh-HK" altLang="zh-HK" sz="1400" dirty="0"/>
+              <a:t>SA4 summaries are not school-zone values.</a:t>
+            </a:r>
+          </a:p>
+          <a:p>
+            <a:pPr>
+              <a:buNone/>
+            </a:pPr>
+            <a:r>
+              <a:rPr lang="zh-HK" altLang="zh-HK" sz="1400" dirty="0"/>
+              <a:t>Draft design. All points and boundaries are illustrative. Final measures and scales must match the dataset.</a:t>
+            </a:r>
+          </a:p>
+        </p:txBody>
+      </p:sp>
+      <p:sp>
+        <p:nvSpPr>
+          <p:cNvPr id="123" name="文字方塊 122">
+            <a:extLst>
+              <a:ext uri="{FF2B5EF4-FFF2-40B4-BE49-F238E27FC236}">
+                <a16:creationId xmlns:a16="http://schemas.microsoft.com/office/drawing/2014/main" id="{90EF12C5-26F2-8DF0-9555-C8432349A05B}"/>
+              </a:ext>
+            </a:extLst>
+          </p:cNvPr>
+          <p:cNvSpPr txBox="1"/>
+          <p:nvPr/>
+        </p:nvSpPr>
+        <p:spPr>
+          <a:xfrm>
+            <a:off x="3829975" y="2822989"/>
+            <a:ext cx="1966517" cy="307777"/>
+          </a:xfrm>
+          <a:prstGeom prst="rect">
+            <a:avLst/>
+          </a:prstGeom>
+          <a:noFill/>
+        </p:spPr>
+        <p:txBody>
+          <a:bodyPr wrap="square">
+            <a:spAutoFit/>
+          </a:bodyPr>
+          <a:lstStyle/>
+          <a:p>
+            <a:r>
+              <a:rPr lang="zh-HK" altLang="zh-HK" sz="1400" dirty="0"/>
+              <a:t>Clickable progress bar</a:t>
+            </a:r>
+            <a:endParaRPr lang="zh-HK" altLang="en-US" sz="1400" dirty="0"/>
+          </a:p>
+        </p:txBody>
+      </p:sp>
+      <p:pic>
+        <p:nvPicPr>
+          <p:cNvPr id="125" name="圖片 124">
+            <a:extLst>
+              <a:ext uri="{FF2B5EF4-FFF2-40B4-BE49-F238E27FC236}">
+                <a16:creationId xmlns:a16="http://schemas.microsoft.com/office/drawing/2014/main" id="{7A7C2504-8E05-FF0D-96AB-CF0464092A68}"/>
+              </a:ext>
+            </a:extLst>
+          </p:cNvPr>
+          <p:cNvPicPr>
+            <a:picLocks noChangeAspect="1"/>
+          </p:cNvPicPr>
+          <p:nvPr/>
+        </p:nvPicPr>
+        <p:blipFill>
+          <a:blip r:embed="rId9"/>
+          <a:stretch>
+            <a:fillRect/>
+          </a:stretch>
+        </p:blipFill>
+        <p:spPr>
+          <a:xfrm>
+            <a:off x="8492" y="7084435"/>
+            <a:ext cx="3560338" cy="1877591"/>
+          </a:xfrm>
+          <a:prstGeom prst="rect">
+            <a:avLst/>
+          </a:prstGeom>
+        </p:spPr>
+      </p:pic>
+      <p:pic>
+        <p:nvPicPr>
+          <p:cNvPr id="127" name="圖片 126">
+            <a:extLst>
+              <a:ext uri="{FF2B5EF4-FFF2-40B4-BE49-F238E27FC236}">
+                <a16:creationId xmlns:a16="http://schemas.microsoft.com/office/drawing/2014/main" id="{B2DE9534-84B9-3A3B-70C2-4D73A8BB9431}"/>
+              </a:ext>
+            </a:extLst>
+          </p:cNvPr>
+          <p:cNvPicPr>
+            <a:picLocks noChangeAspect="1"/>
+          </p:cNvPicPr>
+          <p:nvPr/>
+        </p:nvPicPr>
+        <p:blipFill>
+          <a:blip r:embed="rId10"/>
+          <a:stretch>
+            <a:fillRect/>
+          </a:stretch>
+        </p:blipFill>
+        <p:spPr>
+          <a:xfrm>
+            <a:off x="3442739" y="7029978"/>
+            <a:ext cx="3395478" cy="1451100"/>
+          </a:xfrm>
+          <a:prstGeom prst="rect">
+            <a:avLst/>
+          </a:prstGeom>
+        </p:spPr>
+      </p:pic>
+      <p:pic>
+        <p:nvPicPr>
+          <p:cNvPr id="129" name="圖片 128">
+            <a:extLst>
+              <a:ext uri="{FF2B5EF4-FFF2-40B4-BE49-F238E27FC236}">
+                <a16:creationId xmlns:a16="http://schemas.microsoft.com/office/drawing/2014/main" id="{9FCD77CD-7A49-6BEA-EED0-7A54A62E4332}"/>
+              </a:ext>
+            </a:extLst>
+          </p:cNvPr>
+          <p:cNvPicPr>
+            <a:picLocks noChangeAspect="1"/>
+          </p:cNvPicPr>
+          <p:nvPr/>
+        </p:nvPicPr>
+        <p:blipFill>
+          <a:blip r:embed="rId11"/>
+          <a:stretch>
+            <a:fillRect/>
+          </a:stretch>
+        </p:blipFill>
+        <p:spPr>
+          <a:xfrm>
+            <a:off x="6662028" y="8242840"/>
+            <a:ext cx="2887254" cy="1968581"/>
+          </a:xfrm>
+          <a:prstGeom prst="rect">
+            <a:avLst/>
+          </a:prstGeom>
+        </p:spPr>
+      </p:pic>
+      <p:sp>
+        <p:nvSpPr>
+          <p:cNvPr id="137" name="文字方塊 136">
+            <a:extLst>
+              <a:ext uri="{FF2B5EF4-FFF2-40B4-BE49-F238E27FC236}">
+                <a16:creationId xmlns:a16="http://schemas.microsoft.com/office/drawing/2014/main" id="{BAB481DF-F5BC-97AD-5769-7D2F644E2E25}"/>
+              </a:ext>
+            </a:extLst>
+          </p:cNvPr>
+          <p:cNvSpPr txBox="1"/>
+          <p:nvPr/>
+        </p:nvSpPr>
+        <p:spPr>
+          <a:xfrm>
+            <a:off x="10439400" y="106978"/>
+            <a:ext cx="9779000" cy="369332"/>
+          </a:xfrm>
+          <a:prstGeom prst="rect">
+            <a:avLst/>
+          </a:prstGeom>
+          <a:noFill/>
+        </p:spPr>
+        <p:txBody>
+          <a:bodyPr wrap="square">
+            <a:spAutoFit/>
+          </a:bodyPr>
+          <a:lstStyle/>
+          <a:p>
+            <a:r>
+              <a:rPr lang="zh-HK" altLang="zh-HK" dirty="0"/>
+              <a:t>Choosing a Secondary School Zone: Results, Student Backgrounds and Trends</a:t>
+            </a:r>
+            <a:endParaRPr lang="zh-HK" altLang="en-US" dirty="0"/>
           </a:p>
         </p:txBody>
       </p:sp>
@@ -7840,15 +9824,15 @@
         </p:nvSpPr>
         <p:spPr>
           <a:xfrm>
-            <a:off x="188640" y="134436"/>
-            <a:ext cx="756791" cy="297180"/>
+            <a:off x="99150" y="141192"/>
+            <a:ext cx="1030560" cy="300082"/>
           </a:xfrm>
           <a:prstGeom prst="rect">
             <a:avLst/>
           </a:prstGeom>
         </p:spPr>
         <p:txBody>
-          <a:bodyPr lIns="0" tIns="0" rIns="0" bIns="0" rtlCol="0" anchor="t">
+          <a:bodyPr wrap="square" lIns="0" tIns="0" rIns="0" bIns="0" rtlCol="0" anchor="t">
             <a:spAutoFit/>
           </a:bodyPr>
           <a:lstStyle/>
@@ -7862,7 +9846,7 @@
               </a:spcBef>
             </a:pPr>
             <a:r>
-              <a:rPr lang="en-US" sz="1800">
+              <a:rPr lang="en-US" sz="1800" dirty="0">
                 <a:solidFill>
                   <a:srgbClr val="000000"/>
                 </a:solidFill>
@@ -7981,8 +9965,8 @@
         </p:nvGrpSpPr>
         <p:grpSpPr>
           <a:xfrm>
-            <a:off x="9695177" y="5307795"/>
-            <a:ext cx="8592823" cy="4979205"/>
+            <a:off x="9695177" y="6982976"/>
+            <a:ext cx="8592823" cy="3304024"/>
             <a:chOff x="0" y="0"/>
             <a:chExt cx="2263130" cy="1311395"/>
           </a:xfrm>
@@ -8070,103 +10054,6 @@
           </p:txBody>
         </p:sp>
       </p:grpSp>
-      <p:grpSp>
-        <p:nvGrpSpPr>
-          <p:cNvPr id="12" name="Group 12"/>
-          <p:cNvGrpSpPr/>
-          <p:nvPr/>
-        </p:nvGrpSpPr>
-        <p:grpSpPr>
-          <a:xfrm>
-            <a:off x="9695177" y="1672088"/>
-            <a:ext cx="8592823" cy="3635707"/>
-            <a:chOff x="0" y="0"/>
-            <a:chExt cx="2263130" cy="957552"/>
-          </a:xfrm>
-        </p:grpSpPr>
-        <p:sp>
-          <p:nvSpPr>
-            <p:cNvPr id="13" name="Freeform 13"/>
-            <p:cNvSpPr/>
-            <p:nvPr/>
-          </p:nvSpPr>
-          <p:spPr>
-            <a:xfrm>
-              <a:off x="0" y="0"/>
-              <a:ext cx="2263130" cy="957552"/>
-            </a:xfrm>
-            <a:custGeom>
-              <a:avLst/>
-              <a:gdLst/>
-              <a:ahLst/>
-              <a:cxnLst/>
-              <a:rect l="l" t="t" r="r" b="b"/>
-              <a:pathLst>
-                <a:path w="2263130" h="957552">
-                  <a:moveTo>
-                    <a:pt x="0" y="0"/>
-                  </a:moveTo>
-                  <a:lnTo>
-                    <a:pt x="2263130" y="0"/>
-                  </a:lnTo>
-                  <a:lnTo>
-                    <a:pt x="2263130" y="957552"/>
-                  </a:lnTo>
-                  <a:lnTo>
-                    <a:pt x="0" y="957552"/>
-                  </a:lnTo>
-                  <a:close/>
-                </a:path>
-              </a:pathLst>
-            </a:custGeom>
-            <a:ln w="9525" cap="sq">
-              <a:solidFill>
-                <a:srgbClr val="000000"/>
-              </a:solidFill>
-              <a:prstDash val="solid"/>
-              <a:miter/>
-            </a:ln>
-          </p:spPr>
-          <p:txBody>
-            <a:bodyPr/>
-            <a:lstStyle/>
-            <a:p>
-              <a:endParaRPr lang="zh-HK" altLang="en-US"/>
-            </a:p>
-          </p:txBody>
-        </p:sp>
-        <p:sp>
-          <p:nvSpPr>
-            <p:cNvPr id="14" name="TextBox 14"/>
-            <p:cNvSpPr txBox="1"/>
-            <p:nvPr/>
-          </p:nvSpPr>
-          <p:spPr>
-            <a:xfrm>
-              <a:off x="0" y="-38100"/>
-              <a:ext cx="2263130" cy="995652"/>
-            </a:xfrm>
-            <a:prstGeom prst="rect">
-              <a:avLst/>
-            </a:prstGeom>
-          </p:spPr>
-          <p:txBody>
-            <a:bodyPr lIns="50800" tIns="50800" rIns="50800" bIns="50800" rtlCol="0" anchor="ctr"/>
-            <a:lstStyle/>
-            <a:p>
-              <a:pPr algn="ctr">
-                <a:lnSpc>
-                  <a:spcPts val="2659"/>
-                </a:lnSpc>
-                <a:spcBef>
-                  <a:spcPct val="0"/>
-                </a:spcBef>
-              </a:pPr>
-              <a:endParaRPr/>
-            </a:p>
-          </p:txBody>
-        </p:sp>
-      </p:grpSp>
       <p:sp>
         <p:nvSpPr>
           <p:cNvPr id="15" name="TextBox 15"/>
@@ -8175,15 +10062,15 @@
         </p:nvSpPr>
         <p:spPr>
           <a:xfrm>
-            <a:off x="9847017" y="1824488"/>
-            <a:ext cx="1227609" cy="297180"/>
+            <a:off x="9847017" y="1824487"/>
+            <a:ext cx="1582983" cy="300082"/>
           </a:xfrm>
           <a:prstGeom prst="rect">
             <a:avLst/>
           </a:prstGeom>
         </p:spPr>
         <p:txBody>
-          <a:bodyPr lIns="0" tIns="0" rIns="0" bIns="0" rtlCol="0" anchor="t">
+          <a:bodyPr wrap="square" lIns="0" tIns="0" rIns="0" bIns="0" rtlCol="0" anchor="t">
             <a:spAutoFit/>
           </a:bodyPr>
           <a:lstStyle/>
@@ -8197,7 +10084,7 @@
               </a:spcBef>
             </a:pPr>
             <a:r>
-              <a:rPr lang="en-US" sz="1800">
+              <a:rPr lang="en-US" sz="1800" dirty="0">
                 <a:solidFill>
                   <a:srgbClr val="000000"/>
                 </a:solidFill>
@@ -8263,7 +10150,7 @@
         </p:nvSpPr>
         <p:spPr>
           <a:xfrm>
-            <a:off x="9847017" y="5479245"/>
+            <a:off x="9865392" y="7079231"/>
             <a:ext cx="3940022" cy="297180"/>
           </a:xfrm>
           <a:prstGeom prst="rect">
@@ -8285,7 +10172,7 @@
               </a:spcBef>
             </a:pPr>
             <a:r>
-              <a:rPr lang="en-US" sz="1800">
+              <a:rPr lang="en-US" sz="1800" dirty="0">
                 <a:solidFill>
                   <a:srgbClr val="000000"/>
                 </a:solidFill>
@@ -8696,14 +10583,14 @@
         <p:spPr>
           <a:xfrm>
             <a:off x="9780580" y="117926"/>
-            <a:ext cx="543744" cy="297179"/>
+            <a:ext cx="658820" cy="300082"/>
           </a:xfrm>
           <a:prstGeom prst="rect">
             <a:avLst/>
           </a:prstGeom>
         </p:spPr>
         <p:txBody>
-          <a:bodyPr lIns="0" tIns="0" rIns="0" bIns="0" rtlCol="0" anchor="t">
+          <a:bodyPr wrap="square" lIns="0" tIns="0" rIns="0" bIns="0" rtlCol="0" anchor="t">
             <a:spAutoFit/>
           </a:bodyPr>
           <a:lstStyle/>
@@ -8717,7 +10604,7 @@
               </a:spcBef>
             </a:pPr>
             <a:r>
-              <a:rPr lang="en-US" sz="1800">
+              <a:rPr lang="en-US" sz="1800" dirty="0">
                 <a:solidFill>
                   <a:srgbClr val="000000"/>
                 </a:solidFill>
@@ -8740,14 +10627,14 @@
         <p:spPr>
           <a:xfrm>
             <a:off x="9780580" y="652888"/>
-            <a:ext cx="825326" cy="297180"/>
+            <a:ext cx="1113006" cy="300082"/>
           </a:xfrm>
           <a:prstGeom prst="rect">
             <a:avLst/>
           </a:prstGeom>
         </p:spPr>
         <p:txBody>
-          <a:bodyPr lIns="0" tIns="0" rIns="0" bIns="0" rtlCol="0" anchor="t">
+          <a:bodyPr wrap="square" lIns="0" tIns="0" rIns="0" bIns="0" rtlCol="0" anchor="t">
             <a:spAutoFit/>
           </a:bodyPr>
           <a:lstStyle/>
@@ -8968,15 +10855,15 @@
         </p:nvSpPr>
         <p:spPr>
           <a:xfrm>
-            <a:off x="9780580" y="1189613"/>
-            <a:ext cx="533772" cy="297180"/>
+            <a:off x="9780580" y="1189612"/>
+            <a:ext cx="825326" cy="311025"/>
           </a:xfrm>
           <a:prstGeom prst="rect">
             <a:avLst/>
           </a:prstGeom>
         </p:spPr>
         <p:txBody>
-          <a:bodyPr lIns="0" tIns="0" rIns="0" bIns="0" rtlCol="0" anchor="t">
+          <a:bodyPr wrap="square" lIns="0" tIns="0" rIns="0" bIns="0" rtlCol="0" anchor="t">
             <a:spAutoFit/>
           </a:bodyPr>
           <a:lstStyle/>
@@ -8990,7 +10877,7 @@
               </a:spcBef>
             </a:pPr>
             <a:r>
-              <a:rPr lang="en-US" sz="1800">
+              <a:rPr lang="en-US" sz="1800" dirty="0">
                 <a:solidFill>
                   <a:srgbClr val="000000"/>
                 </a:solidFill>
@@ -9004,6 +10891,1492 @@
           </a:p>
         </p:txBody>
       </p:sp>
+      <p:sp>
+        <p:nvSpPr>
+          <p:cNvPr id="39" name="文字方塊 38">
+            <a:extLst>
+              <a:ext uri="{FF2B5EF4-FFF2-40B4-BE49-F238E27FC236}">
+                <a16:creationId xmlns:a16="http://schemas.microsoft.com/office/drawing/2014/main" id="{1083649D-F6CD-0BA1-8EC9-9E6A7F51F255}"/>
+              </a:ext>
+            </a:extLst>
+          </p:cNvPr>
+          <p:cNvSpPr txBox="1"/>
+          <p:nvPr/>
+        </p:nvSpPr>
+        <p:spPr>
+          <a:xfrm>
+            <a:off x="10809232" y="612554"/>
+            <a:ext cx="1523174" cy="369332"/>
+          </a:xfrm>
+          <a:prstGeom prst="rect">
+            <a:avLst/>
+          </a:prstGeom>
+          <a:noFill/>
+        </p:spPr>
+        <p:txBody>
+          <a:bodyPr wrap="none" rtlCol="0">
+            <a:spAutoFit/>
+          </a:bodyPr>
+          <a:lstStyle/>
+          <a:p>
+            <a:r>
+              <a:rPr lang="en-US" altLang="zh-HK" dirty="0"/>
+              <a:t>Sin Ping CHAN</a:t>
+            </a:r>
+            <a:endParaRPr lang="zh-HK" altLang="en-US" dirty="0"/>
+          </a:p>
+        </p:txBody>
+      </p:sp>
+      <p:sp>
+        <p:nvSpPr>
+          <p:cNvPr id="41" name="文字方塊 40">
+            <a:extLst>
+              <a:ext uri="{FF2B5EF4-FFF2-40B4-BE49-F238E27FC236}">
+                <a16:creationId xmlns:a16="http://schemas.microsoft.com/office/drawing/2014/main" id="{69ACD2E1-B17D-22E7-C68F-2024E8FA66B1}"/>
+              </a:ext>
+            </a:extLst>
+          </p:cNvPr>
+          <p:cNvSpPr txBox="1"/>
+          <p:nvPr/>
+        </p:nvSpPr>
+        <p:spPr>
+          <a:xfrm>
+            <a:off x="14192148" y="623600"/>
+            <a:ext cx="1300356" cy="369332"/>
+          </a:xfrm>
+          <a:prstGeom prst="rect">
+            <a:avLst/>
+          </a:prstGeom>
+          <a:noFill/>
+        </p:spPr>
+        <p:txBody>
+          <a:bodyPr wrap="none" rtlCol="0">
+            <a:spAutoFit/>
+          </a:bodyPr>
+          <a:lstStyle/>
+          <a:p>
+            <a:r>
+              <a:rPr lang="en-US" altLang="zh-HK" dirty="0"/>
+              <a:t>08/10/2026</a:t>
+            </a:r>
+            <a:endParaRPr lang="zh-HK" altLang="en-US" dirty="0"/>
+          </a:p>
+        </p:txBody>
+      </p:sp>
+      <p:sp>
+        <p:nvSpPr>
+          <p:cNvPr id="43" name="文字方塊 42">
+            <a:extLst>
+              <a:ext uri="{FF2B5EF4-FFF2-40B4-BE49-F238E27FC236}">
+                <a16:creationId xmlns:a16="http://schemas.microsoft.com/office/drawing/2014/main" id="{2FFA90AF-193D-E602-0C11-54E302D68DC7}"/>
+              </a:ext>
+            </a:extLst>
+          </p:cNvPr>
+          <p:cNvSpPr txBox="1"/>
+          <p:nvPr/>
+        </p:nvSpPr>
+        <p:spPr>
+          <a:xfrm>
+            <a:off x="17330721" y="604168"/>
+            <a:ext cx="301686" cy="369332"/>
+          </a:xfrm>
+          <a:prstGeom prst="rect">
+            <a:avLst/>
+          </a:prstGeom>
+          <a:noFill/>
+        </p:spPr>
+        <p:txBody>
+          <a:bodyPr wrap="none" rtlCol="0">
+            <a:spAutoFit/>
+          </a:bodyPr>
+          <a:lstStyle/>
+          <a:p>
+            <a:r>
+              <a:rPr lang="en-US" altLang="zh-HK" dirty="0"/>
+              <a:t>3</a:t>
+            </a:r>
+            <a:endParaRPr lang="zh-HK" altLang="en-US" dirty="0"/>
+          </a:p>
+        </p:txBody>
+      </p:sp>
+      <p:sp>
+        <p:nvSpPr>
+          <p:cNvPr id="45" name="文字方塊 44">
+            <a:extLst>
+              <a:ext uri="{FF2B5EF4-FFF2-40B4-BE49-F238E27FC236}">
+                <a16:creationId xmlns:a16="http://schemas.microsoft.com/office/drawing/2014/main" id="{9EDE1A1C-0E4B-1059-EDA9-D42CED5B8CF3}"/>
+              </a:ext>
+            </a:extLst>
+          </p:cNvPr>
+          <p:cNvSpPr txBox="1"/>
+          <p:nvPr/>
+        </p:nvSpPr>
+        <p:spPr>
+          <a:xfrm>
+            <a:off x="10439400" y="106978"/>
+            <a:ext cx="9779000" cy="369332"/>
+          </a:xfrm>
+          <a:prstGeom prst="rect">
+            <a:avLst/>
+          </a:prstGeom>
+          <a:noFill/>
+        </p:spPr>
+        <p:txBody>
+          <a:bodyPr wrap="square">
+            <a:spAutoFit/>
+          </a:bodyPr>
+          <a:lstStyle/>
+          <a:p>
+            <a:r>
+              <a:rPr lang="zh-HK" altLang="zh-HK" dirty="0"/>
+              <a:t>Choosing a Secondary School Zone: Results, Student Backgrounds and Trends</a:t>
+            </a:r>
+            <a:endParaRPr lang="zh-HK" altLang="en-US" dirty="0"/>
+          </a:p>
+        </p:txBody>
+      </p:sp>
+      <p:sp>
+        <p:nvSpPr>
+          <p:cNvPr id="47" name="文字方塊 46">
+            <a:extLst>
+              <a:ext uri="{FF2B5EF4-FFF2-40B4-BE49-F238E27FC236}">
+                <a16:creationId xmlns:a16="http://schemas.microsoft.com/office/drawing/2014/main" id="{E924F0B2-9287-92C5-5D95-DF15EF4FFBD7}"/>
+              </a:ext>
+            </a:extLst>
+          </p:cNvPr>
+          <p:cNvSpPr txBox="1"/>
+          <p:nvPr/>
+        </p:nvSpPr>
+        <p:spPr>
+          <a:xfrm>
+            <a:off x="9990056" y="2220561"/>
+            <a:ext cx="8404183" cy="5447645"/>
+          </a:xfrm>
+          <a:prstGeom prst="rect">
+            <a:avLst/>
+          </a:prstGeom>
+          <a:noFill/>
+        </p:spPr>
+        <p:txBody>
+          <a:bodyPr wrap="square">
+            <a:spAutoFit/>
+          </a:bodyPr>
+          <a:lstStyle/>
+          <a:p>
+            <a:r>
+              <a:rPr lang="zh-HK" altLang="zh-HK" sz="1200" b="1" dirty="0"/>
+              <a:t>1. Results</a:t>
+            </a:r>
+            <a:endParaRPr lang="zh-HK" altLang="zh-HK" sz="1200" dirty="0"/>
+          </a:p>
+          <a:p>
+            <a:pPr lvl="0"/>
+            <a:r>
+              <a:rPr lang="zh-HK" altLang="zh-HK" sz="1200" dirty="0"/>
+              <a:t>Select a dot to show the school name, median VCE study score and share of study scores ≥40.</a:t>
+            </a:r>
+          </a:p>
+          <a:p>
+            <a:pPr lvl="0"/>
+            <a:r>
+              <a:rPr lang="zh-HK" altLang="zh-HK" sz="1200" dirty="0"/>
+              <a:t>Select </a:t>
+            </a:r>
+            <a:r>
+              <a:rPr lang="zh-HK" altLang="zh-HK" sz="1200" b="1" dirty="0"/>
+              <a:t>“Focus on government schools”</a:t>
+            </a:r>
+            <a:r>
+              <a:rPr lang="zh-HK" altLang="zh-HK" sz="1200" dirty="0"/>
+              <a:t> to highlight government-school dots while other sectors fade.</a:t>
+            </a:r>
+          </a:p>
+          <a:p>
+            <a:pPr lvl="0"/>
+            <a:r>
+              <a:rPr lang="zh-HK" altLang="zh-HK" sz="1200" dirty="0"/>
+              <a:t>Open Question 2 to explore student background.</a:t>
+            </a:r>
+          </a:p>
+          <a:p>
+            <a:r>
+              <a:rPr lang="zh-HK" altLang="zh-HK" sz="1200" b="1" dirty="0"/>
+              <a:t>2. Background</a:t>
+            </a:r>
+            <a:endParaRPr lang="zh-HK" altLang="zh-HK" sz="1200" dirty="0"/>
+          </a:p>
+          <a:p>
+            <a:pPr lvl="0"/>
+            <a:r>
+              <a:rPr lang="zh-HK" altLang="zh-HK" sz="1200" dirty="0"/>
+              <a:t>Select a school dot to highlight it and show its name.</a:t>
+            </a:r>
+          </a:p>
+          <a:p>
+            <a:pPr lvl="0"/>
+            <a:r>
+              <a:rPr lang="zh-HK" altLang="zh-HK" sz="1200" dirty="0"/>
+              <a:t>Select </a:t>
+            </a:r>
+            <a:r>
+              <a:rPr lang="zh-HK" altLang="zh-HK" sz="1200" b="1" dirty="0"/>
+              <a:t>“See its three-year trend”</a:t>
+            </a:r>
+            <a:r>
+              <a:rPr lang="zh-HK" altLang="zh-HK" sz="1200" dirty="0"/>
+              <a:t> to reveal a small line chart.</a:t>
+            </a:r>
+          </a:p>
+          <a:p>
+            <a:pPr lvl="0"/>
+            <a:r>
+              <a:rPr lang="zh-HK" altLang="zh-HK" sz="1200" dirty="0"/>
+              <a:t>Close the trend to return to the scatter plot.</a:t>
+            </a:r>
+          </a:p>
+          <a:p>
+            <a:pPr lvl="0"/>
+            <a:r>
+              <a:rPr lang="zh-HK" altLang="zh-HK" sz="1200" dirty="0"/>
+              <a:t>Open Question 3 to explore the four profiles.</a:t>
+            </a:r>
+          </a:p>
+          <a:p>
+            <a:r>
+              <a:rPr lang="zh-HK" altLang="zh-HK" sz="1200" b="1" dirty="0"/>
+              <a:t>3. Profiles</a:t>
+            </a:r>
+            <a:endParaRPr lang="zh-HK" altLang="zh-HK" sz="1200" dirty="0"/>
+          </a:p>
+          <a:p>
+            <a:pPr lvl="0"/>
+            <a:r>
+              <a:rPr lang="zh-HK" altLang="zh-HK" sz="1200" dirty="0"/>
+              <a:t>Select a profile circle to highlight it.</a:t>
+            </a:r>
+          </a:p>
+          <a:p>
+            <a:pPr lvl="0"/>
+            <a:r>
+              <a:rPr lang="zh-HK" altLang="zh-HK" sz="1200" dirty="0"/>
+              <a:t>Show its school count and five average values.</a:t>
+            </a:r>
+          </a:p>
+          <a:p>
+            <a:pPr lvl="0"/>
+            <a:r>
+              <a:rPr lang="zh-HK" altLang="zh-HK" sz="1200" dirty="0"/>
+              <a:t>Group the values under </a:t>
+            </a:r>
+            <a:r>
+              <a:rPr lang="zh-HK" altLang="zh-HK" sz="1200" b="1" dirty="0"/>
+              <a:t>Current results</a:t>
+            </a:r>
+            <a:r>
+              <a:rPr lang="zh-HK" altLang="zh-HK" sz="1200" dirty="0"/>
+              <a:t>, </a:t>
+            </a:r>
+            <a:r>
+              <a:rPr lang="zh-HK" altLang="zh-HK" sz="1200" b="1" dirty="0"/>
+              <a:t>Recent change</a:t>
+            </a:r>
+            <a:r>
+              <a:rPr lang="zh-HK" altLang="zh-HK" sz="1200" dirty="0"/>
+              <a:t> and </a:t>
+            </a:r>
+            <a:r>
+              <a:rPr lang="zh-HK" altLang="zh-HK" sz="1200" b="1" dirty="0"/>
+              <a:t>Student background</a:t>
+            </a:r>
+            <a:r>
+              <a:rPr lang="zh-HK" altLang="zh-HK" sz="1200" dirty="0"/>
+              <a:t>.</a:t>
+            </a:r>
+          </a:p>
+          <a:p>
+            <a:pPr lvl="0"/>
+            <a:r>
+              <a:rPr lang="zh-HK" altLang="zh-HK" sz="1200" dirty="0"/>
+              <a:t>Show median-score change in points and high-score-share change in percentage points.</a:t>
+            </a:r>
+          </a:p>
+          <a:p>
+            <a:pPr lvl="0"/>
+            <a:r>
+              <a:rPr lang="zh-HK" altLang="zh-HK" sz="1200" dirty="0"/>
+              <a:t>Add a short explanation of the profile’s main features.</a:t>
+            </a:r>
+          </a:p>
+          <a:p>
+            <a:pPr lvl="0"/>
+            <a:r>
+              <a:rPr lang="zh-HK" altLang="zh-HK" sz="1200" dirty="0"/>
+              <a:t>Select </a:t>
+            </a:r>
+            <a:r>
+              <a:rPr lang="zh-HK" altLang="zh-HK" sz="1200" b="1" dirty="0"/>
+              <a:t>“Where are these schools?”</a:t>
+            </a:r>
+            <a:r>
+              <a:rPr lang="zh-HK" altLang="zh-HK" sz="1200" dirty="0"/>
+              <a:t> to open Question 4 with the same profile selected.</a:t>
+            </a:r>
+          </a:p>
+          <a:p>
+            <a:r>
+              <a:rPr lang="zh-HK" altLang="zh-HK" sz="1200" b="1" dirty="0"/>
+              <a:t>4. Locations</a:t>
+            </a:r>
+            <a:endParaRPr lang="zh-HK" altLang="zh-HK" sz="1200" dirty="0"/>
+          </a:p>
+          <a:p>
+            <a:pPr lvl="0"/>
+            <a:r>
+              <a:rPr lang="zh-HK" altLang="zh-HK" sz="1200" dirty="0"/>
+              <a:t>Highlight school zones linked to schools in the selected profile.</a:t>
+            </a:r>
+          </a:p>
+          <a:p>
+            <a:pPr lvl="0"/>
+            <a:r>
+              <a:rPr lang="zh-HK" altLang="zh-HK" sz="1200" dirty="0"/>
+              <a:t>Other zones fade but remain visible for context.</a:t>
+            </a:r>
+          </a:p>
+          <a:p>
+            <a:pPr lvl="0"/>
+            <a:r>
+              <a:rPr lang="zh-HK" altLang="zh-HK" sz="1200" dirty="0"/>
+              <a:t>Select another profile label to update the map and explanation.</a:t>
+            </a:r>
+          </a:p>
+          <a:p>
+            <a:pPr lvl="0"/>
+            <a:r>
+              <a:rPr lang="zh-HK" altLang="zh-HK" sz="1200" dirty="0"/>
+              <a:t>Keep SA4 outlines and names visible.</a:t>
+            </a:r>
+          </a:p>
+          <a:p>
+            <a:pPr lvl="0"/>
+            <a:r>
+              <a:rPr lang="zh-HK" altLang="zh-HK" sz="1200" dirty="0"/>
+              <a:t>Individual zones do not open information cards in this section.</a:t>
+            </a:r>
+          </a:p>
+          <a:p>
+            <a:pPr lvl="0"/>
+            <a:r>
+              <a:rPr lang="zh-HK" altLang="zh-HK" sz="1200" dirty="0"/>
+              <a:t>Open Question 5 to read school-zone details.</a:t>
+            </a:r>
+          </a:p>
+          <a:p>
+            <a:r>
+              <a:rPr lang="zh-HK" altLang="zh-HK" sz="1200" b="1" dirty="0"/>
+              <a:t>5. School zones</a:t>
+            </a:r>
+            <a:endParaRPr lang="zh-HK" altLang="zh-HK" sz="1200" dirty="0"/>
+          </a:p>
+          <a:p>
+            <a:pPr lvl="0"/>
+            <a:r>
+              <a:rPr lang="zh-HK" altLang="zh-HK" sz="1200" dirty="0"/>
+              <a:t>Move the labelled results slider to highlight matching zones.</a:t>
+            </a:r>
+          </a:p>
+          <a:p>
+            <a:pPr lvl="0"/>
+            <a:r>
+              <a:rPr lang="zh-HK" altLang="zh-HK" sz="1200" dirty="0"/>
+              <a:t>Select a zone to open its associated school’s information card.</a:t>
+            </a:r>
+          </a:p>
+          <a:p>
+            <a:pPr lvl="0"/>
+            <a:r>
+              <a:rPr lang="zh-HK" altLang="zh-HK" sz="1200" dirty="0"/>
+              <a:t>Show results and year, ICSEA, three-year change, available course information, data source and zone reference year.</a:t>
+            </a:r>
+          </a:p>
+          <a:p>
+            <a:pPr lvl="0"/>
+            <a:r>
+              <a:rPr lang="zh-HK" altLang="zh-HK" sz="1200" dirty="0"/>
+              <a:t>Close the card to return to the map.</a:t>
+            </a:r>
+          </a:p>
+          <a:p>
+            <a:pPr lvl="0"/>
+            <a:r>
+              <a:rPr lang="zh-HK" altLang="zh-HK" sz="1200" dirty="0"/>
+              <a:t>Do not include shortlist or comparison controls.</a:t>
+            </a:r>
+          </a:p>
+        </p:txBody>
+      </p:sp>
+      <p:sp>
+        <p:nvSpPr>
+          <p:cNvPr id="49" name="文字方塊 48">
+            <a:extLst>
+              <a:ext uri="{FF2B5EF4-FFF2-40B4-BE49-F238E27FC236}">
+                <a16:creationId xmlns:a16="http://schemas.microsoft.com/office/drawing/2014/main" id="{5527BF44-BABB-B96C-CF5C-335F75872D79}"/>
+              </a:ext>
+            </a:extLst>
+          </p:cNvPr>
+          <p:cNvSpPr txBox="1"/>
+          <p:nvPr/>
+        </p:nvSpPr>
+        <p:spPr>
+          <a:xfrm>
+            <a:off x="11240289" y="6986079"/>
+            <a:ext cx="7047711" cy="3323987"/>
+          </a:xfrm>
+          <a:prstGeom prst="rect">
+            <a:avLst/>
+          </a:prstGeom>
+          <a:noFill/>
+        </p:spPr>
+        <p:txBody>
+          <a:bodyPr wrap="square">
+            <a:spAutoFit/>
+          </a:bodyPr>
+          <a:lstStyle/>
+          <a:p>
+            <a:r>
+              <a:rPr lang="zh-HK" altLang="zh-HK" sz="1400" b="1" dirty="0"/>
+              <a:t>Strengths</a:t>
+            </a:r>
+            <a:endParaRPr lang="zh-HK" altLang="zh-HK" sz="1400" dirty="0"/>
+          </a:p>
+          <a:p>
+            <a:pPr marL="285750" lvl="0" indent="-285750">
+              <a:buFont typeface="Arial" panose="020B0604020202020204" pitchFamily="34" charset="0"/>
+              <a:buChar char="•"/>
+            </a:pPr>
+            <a:r>
+              <a:rPr lang="zh-HK" altLang="zh-HK" sz="1400" dirty="0"/>
+              <a:t>One question per slide keeps the message clear.</a:t>
+            </a:r>
+          </a:p>
+          <a:p>
+            <a:pPr marL="285750" lvl="0" indent="-285750">
+              <a:buFont typeface="Arial" panose="020B0604020202020204" pitchFamily="34" charset="0"/>
+              <a:buChar char="•"/>
+            </a:pPr>
+            <a:r>
+              <a:rPr lang="zh-HK" altLang="zh-HK" sz="1400" dirty="0"/>
+              <a:t>Readers control the pace and can return easily.</a:t>
+            </a:r>
+          </a:p>
+          <a:p>
+            <a:pPr marL="285750" lvl="0" indent="-285750">
+              <a:buFont typeface="Arial" panose="020B0604020202020204" pitchFamily="34" charset="0"/>
+              <a:buChar char="•"/>
+            </a:pPr>
+            <a:r>
+              <a:rPr lang="zh-HK" altLang="zh-HK" sz="1400" dirty="0"/>
+              <a:t>A fixed visual area provides a consistent layout.</a:t>
+            </a:r>
+          </a:p>
+          <a:p>
+            <a:pPr marL="285750" lvl="0" indent="-285750">
+              <a:buFont typeface="Arial" panose="020B0604020202020204" pitchFamily="34" charset="0"/>
+              <a:buChar char="•"/>
+            </a:pPr>
+            <a:r>
+              <a:rPr lang="zh-HK" altLang="zh-HK" sz="1400" dirty="0"/>
+              <a:t>The selected profile connects the explanation to the next map.</a:t>
+            </a:r>
+          </a:p>
+          <a:p>
+            <a:r>
+              <a:rPr lang="zh-HK" altLang="zh-HK" sz="1400" b="1" dirty="0"/>
+              <a:t>Trade-offs</a:t>
+            </a:r>
+            <a:endParaRPr lang="zh-HK" altLang="zh-HK" sz="1400" dirty="0"/>
+          </a:p>
+          <a:p>
+            <a:pPr marL="285750" lvl="0" indent="-285750">
+              <a:buFont typeface="Arial" panose="020B0604020202020204" pitchFamily="34" charset="0"/>
+              <a:buChar char="•"/>
+            </a:pPr>
+            <a:r>
+              <a:rPr lang="zh-HK" altLang="zh-HK" sz="1400" dirty="0"/>
+              <a:t>Readers must click to continue.</a:t>
+            </a:r>
+          </a:p>
+          <a:p>
+            <a:pPr marL="285750" lvl="0" indent="-285750">
+              <a:buFont typeface="Arial" panose="020B0604020202020204" pitchFamily="34" charset="0"/>
+              <a:buChar char="•"/>
+            </a:pPr>
+            <a:r>
+              <a:rPr lang="zh-HK" altLang="zh-HK" sz="1400" dirty="0"/>
+              <a:t>Skipping slides may leave gaps in understanding.</a:t>
+            </a:r>
+          </a:p>
+          <a:p>
+            <a:r>
+              <a:rPr lang="zh-HK" altLang="zh-HK" sz="1400" b="1" dirty="0"/>
+              <a:t>Design notes</a:t>
+            </a:r>
+            <a:endParaRPr lang="zh-HK" altLang="zh-HK" sz="1400" dirty="0"/>
+          </a:p>
+          <a:p>
+            <a:pPr marL="285750" lvl="0" indent="-285750">
+              <a:buFont typeface="Arial" panose="020B0604020202020204" pitchFamily="34" charset="0"/>
+              <a:buChar char="•"/>
+            </a:pPr>
+            <a:r>
+              <a:rPr lang="zh-HK" altLang="zh-HK" sz="1400" dirty="0"/>
+              <a:t>Use clear question titles, direct labels and consistent colours.</a:t>
+            </a:r>
+          </a:p>
+          <a:p>
+            <a:pPr marL="285750" lvl="0" indent="-285750">
+              <a:buFont typeface="Arial" panose="020B0604020202020204" pitchFamily="34" charset="0"/>
+              <a:buChar char="•"/>
+            </a:pPr>
+            <a:r>
+              <a:rPr lang="zh-HK" altLang="zh-HK" sz="1400" dirty="0"/>
+              <a:t>Use profile colours for school-zone shading; use SA4 outlines for location.</a:t>
+            </a:r>
+          </a:p>
+          <a:p>
+            <a:pPr marL="285750" lvl="0" indent="-285750">
+              <a:buFont typeface="Arial" panose="020B0604020202020204" pitchFamily="34" charset="0"/>
+              <a:buChar char="•"/>
+            </a:pPr>
+            <a:r>
+              <a:rPr lang="zh-HK" altLang="zh-HK" sz="1400" dirty="0"/>
+              <a:t>The profiles describe 111 zone-linked government schools with complete data.</a:t>
+            </a:r>
+          </a:p>
+          <a:p>
+            <a:pPr marL="285750" lvl="0" indent="-285750">
+              <a:buFont typeface="Arial" panose="020B0604020202020204" pitchFamily="34" charset="0"/>
+              <a:buChar char="•"/>
+            </a:pPr>
+            <a:r>
+              <a:rPr lang="zh-HK" altLang="zh-HK" sz="1400" dirty="0"/>
+              <a:t>Profile averages are not school-quality grades or predictions.</a:t>
+            </a:r>
+          </a:p>
+          <a:p>
+            <a:pPr marL="285750" lvl="0" indent="-285750">
+              <a:buFont typeface="Arial" panose="020B0604020202020204" pitchFamily="34" charset="0"/>
+              <a:buChar char="•"/>
+            </a:pPr>
+            <a:r>
+              <a:rPr lang="zh-HK" altLang="zh-HK" sz="1400" dirty="0"/>
+              <a:t>Mark unclassified schools separately.</a:t>
+            </a:r>
+          </a:p>
+          <a:p>
+            <a:pPr marL="285750" lvl="0" indent="-285750">
+              <a:buFont typeface="Arial" panose="020B0604020202020204" pitchFamily="34" charset="0"/>
+              <a:buChar char="•"/>
+            </a:pPr>
+            <a:r>
+              <a:rPr lang="zh-HK" altLang="zh-HK" sz="1400" dirty="0"/>
+              <a:t>Keep metric names, years and scales clear.</a:t>
+            </a:r>
+          </a:p>
+        </p:txBody>
+      </p:sp>
+      <p:sp>
+        <p:nvSpPr>
+          <p:cNvPr id="51" name="文字方塊 50">
+            <a:extLst>
+              <a:ext uri="{FF2B5EF4-FFF2-40B4-BE49-F238E27FC236}">
+                <a16:creationId xmlns:a16="http://schemas.microsoft.com/office/drawing/2014/main" id="{24D897D1-87AC-BD41-4990-24A8046D92D4}"/>
+              </a:ext>
+            </a:extLst>
+          </p:cNvPr>
+          <p:cNvSpPr txBox="1"/>
+          <p:nvPr/>
+        </p:nvSpPr>
+        <p:spPr>
+          <a:xfrm>
+            <a:off x="1086121" y="98758"/>
+            <a:ext cx="8523331" cy="646331"/>
+          </a:xfrm>
+          <a:prstGeom prst="rect">
+            <a:avLst/>
+          </a:prstGeom>
+          <a:noFill/>
+        </p:spPr>
+        <p:txBody>
+          <a:bodyPr wrap="square">
+            <a:spAutoFit/>
+          </a:bodyPr>
+          <a:lstStyle/>
+          <a:p>
+            <a:r>
+              <a:rPr lang="zh-HK" altLang="zh-HK" b="1" dirty="0">
+                <a:highlight>
+                  <a:srgbClr val="FFFF00"/>
+                </a:highlight>
+              </a:rPr>
+              <a:t>Genre:</a:t>
+            </a:r>
+            <a:r>
+              <a:rPr lang="zh-HK" altLang="zh-HK" dirty="0">
+                <a:highlight>
+                  <a:srgbClr val="FFFF00"/>
+                </a:highlight>
+              </a:rPr>
+              <a:t> Question-led</a:t>
+            </a:r>
+            <a:r>
+              <a:rPr lang="en-US" altLang="zh-HK" dirty="0">
+                <a:highlight>
+                  <a:srgbClr val="FFFF00"/>
+                </a:highlight>
+              </a:rPr>
+              <a:t> slides</a:t>
+            </a:r>
+            <a:r>
+              <a:rPr lang="zh-HK" altLang="zh-HK" dirty="0">
+                <a:highlight>
+                  <a:srgbClr val="FFFF00"/>
+                </a:highlight>
+              </a:rPr>
+              <a:t> + annotated charts</a:t>
+            </a:r>
+            <a:br>
+              <a:rPr lang="zh-HK" altLang="zh-HK" dirty="0">
+                <a:highlight>
+                  <a:srgbClr val="FFFF00"/>
+                </a:highlight>
+              </a:rPr>
+            </a:br>
+            <a:r>
+              <a:rPr lang="zh-HK" altLang="zh-HK" b="1" dirty="0">
+                <a:highlight>
+                  <a:srgbClr val="FFFF00"/>
+                </a:highlight>
+              </a:rPr>
+              <a:t>Style:</a:t>
+            </a:r>
+            <a:r>
+              <a:rPr lang="zh-HK" altLang="zh-HK" dirty="0">
+                <a:highlight>
+                  <a:srgbClr val="FFFF00"/>
+                </a:highlight>
+              </a:rPr>
+              <a:t> Guided questions with reader-controlled exploration</a:t>
+            </a:r>
+            <a:endParaRPr lang="zh-HK" altLang="en-US" dirty="0">
+              <a:highlight>
+                <a:srgbClr val="FFFF00"/>
+              </a:highlight>
+            </a:endParaRPr>
+          </a:p>
+        </p:txBody>
+      </p:sp>
+      <p:sp>
+        <p:nvSpPr>
+          <p:cNvPr id="53" name="文字方塊 52">
+            <a:extLst>
+              <a:ext uri="{FF2B5EF4-FFF2-40B4-BE49-F238E27FC236}">
+                <a16:creationId xmlns:a16="http://schemas.microsoft.com/office/drawing/2014/main" id="{B71F849C-5BBE-2588-E148-4085646F16B6}"/>
+              </a:ext>
+            </a:extLst>
+          </p:cNvPr>
+          <p:cNvSpPr txBox="1"/>
+          <p:nvPr/>
+        </p:nvSpPr>
+        <p:spPr>
+          <a:xfrm>
+            <a:off x="884733" y="6706647"/>
+            <a:ext cx="7561607" cy="369332"/>
+          </a:xfrm>
+          <a:prstGeom prst="rect">
+            <a:avLst/>
+          </a:prstGeom>
+          <a:noFill/>
+        </p:spPr>
+        <p:txBody>
+          <a:bodyPr wrap="square">
+            <a:spAutoFit/>
+          </a:bodyPr>
+          <a:lstStyle/>
+          <a:p>
+            <a:pPr>
+              <a:buNone/>
+            </a:pPr>
+            <a:r>
+              <a:rPr lang="zh-HK" altLang="zh-HK" b="1" dirty="0">
+                <a:highlight>
+                  <a:srgbClr val="FFFF00"/>
+                </a:highlight>
+              </a:rPr>
+              <a:t>Scene 4 interaction: select, explain, locate</a:t>
+            </a:r>
+            <a:endParaRPr lang="zh-HK" altLang="zh-HK" dirty="0">
+              <a:highlight>
+                <a:srgbClr val="FFFF00"/>
+              </a:highlight>
+            </a:endParaRPr>
+          </a:p>
+        </p:txBody>
+      </p:sp>
+      <p:sp>
+        <p:nvSpPr>
+          <p:cNvPr id="57" name="文字方塊 56">
+            <a:extLst>
+              <a:ext uri="{FF2B5EF4-FFF2-40B4-BE49-F238E27FC236}">
+                <a16:creationId xmlns:a16="http://schemas.microsoft.com/office/drawing/2014/main" id="{9D0CA6E1-2DF4-B4F6-F89D-BE06A9366E9E}"/>
+              </a:ext>
+            </a:extLst>
+          </p:cNvPr>
+          <p:cNvSpPr txBox="1"/>
+          <p:nvPr/>
+        </p:nvSpPr>
+        <p:spPr>
+          <a:xfrm>
+            <a:off x="143005" y="924240"/>
+            <a:ext cx="3785327" cy="2031325"/>
+          </a:xfrm>
+          <a:prstGeom prst="rect">
+            <a:avLst/>
+          </a:prstGeom>
+          <a:noFill/>
+        </p:spPr>
+        <p:txBody>
+          <a:bodyPr wrap="square">
+            <a:spAutoFit/>
+          </a:bodyPr>
+          <a:lstStyle/>
+          <a:p>
+            <a:r>
+              <a:rPr lang="zh-HK" altLang="zh-HK" sz="1400" b="1" dirty="0"/>
+              <a:t>Accordion navigation</a:t>
+            </a:r>
+            <a:endParaRPr lang="zh-HK" altLang="zh-HK" sz="1400" dirty="0"/>
+          </a:p>
+          <a:p>
+            <a:pPr>
+              <a:buNone/>
+            </a:pPr>
+            <a:r>
+              <a:rPr lang="zh-HK" altLang="zh-HK" sz="1400" dirty="0"/>
+              <a:t>Show </a:t>
+            </a:r>
+            <a:r>
+              <a:rPr lang="en-US" altLang="zh-HK" sz="1400" dirty="0"/>
+              <a:t>5</a:t>
+            </a:r>
+            <a:r>
+              <a:rPr lang="zh-HK" altLang="zh-HK" sz="1400" dirty="0"/>
+              <a:t> questions as stacked accordion bars. </a:t>
+            </a:r>
+            <a:endParaRPr lang="en-US" altLang="zh-HK" sz="1400" dirty="0"/>
+          </a:p>
+          <a:p>
+            <a:pPr>
+              <a:buNone/>
+            </a:pPr>
+            <a:r>
+              <a:rPr lang="zh-HK" altLang="zh-HK" sz="1400" dirty="0"/>
+              <a:t>Click a question to reveal its short answer, main visual and explanation. </a:t>
+            </a:r>
+            <a:endParaRPr lang="en-US" altLang="zh-HK" sz="1400" dirty="0"/>
+          </a:p>
+          <a:p>
+            <a:pPr>
+              <a:buNone/>
+            </a:pPr>
+            <a:r>
+              <a:rPr lang="zh-HK" altLang="zh-HK" sz="1400" dirty="0"/>
+              <a:t>Click it again to close it.</a:t>
+            </a:r>
+          </a:p>
+          <a:p>
+            <a:pPr>
+              <a:buNone/>
+            </a:pPr>
+            <a:r>
+              <a:rPr lang="zh-HK" altLang="zh-HK" sz="1400" dirty="0"/>
+              <a:t>Open one question at a time. Opening another closes the previous one. </a:t>
+            </a:r>
+            <a:endParaRPr lang="en-US" altLang="zh-HK" sz="1400" dirty="0"/>
+          </a:p>
+          <a:p>
+            <a:pPr>
+              <a:buNone/>
+            </a:pPr>
+            <a:r>
+              <a:rPr lang="zh-HK" altLang="zh-HK" sz="1400" dirty="0"/>
+              <a:t>Readers can follow the numbered order or choose a question.</a:t>
+            </a:r>
+            <a:endParaRPr lang="en-US" altLang="zh-HK" sz="1400" dirty="0"/>
+          </a:p>
+        </p:txBody>
+      </p:sp>
+      <p:pic>
+        <p:nvPicPr>
+          <p:cNvPr id="59" name="圖片 58">
+            <a:extLst>
+              <a:ext uri="{FF2B5EF4-FFF2-40B4-BE49-F238E27FC236}">
+                <a16:creationId xmlns:a16="http://schemas.microsoft.com/office/drawing/2014/main" id="{C49B67C8-EFED-01A9-FD77-AD221A844277}"/>
+              </a:ext>
+            </a:extLst>
+          </p:cNvPr>
+          <p:cNvPicPr>
+            <a:picLocks noChangeAspect="1"/>
+          </p:cNvPicPr>
+          <p:nvPr/>
+        </p:nvPicPr>
+        <p:blipFill>
+          <a:blip r:embed="rId2">
+            <a:extLst>
+              <a:ext uri="{28A0092B-C50C-407E-A947-70E740481C1C}">
+                <a14:useLocalDpi xmlns:a14="http://schemas.microsoft.com/office/drawing/2010/main" val="0"/>
+              </a:ext>
+            </a:extLst>
+          </a:blip>
+          <a:stretch>
+            <a:fillRect/>
+          </a:stretch>
+        </p:blipFill>
+        <p:spPr>
+          <a:xfrm>
+            <a:off x="7753188" y="5148943"/>
+            <a:ext cx="1790344" cy="1391713"/>
+          </a:xfrm>
+          <a:prstGeom prst="rect">
+            <a:avLst/>
+          </a:prstGeom>
+        </p:spPr>
+      </p:pic>
+      <p:pic>
+        <p:nvPicPr>
+          <p:cNvPr id="61" name="圖片 60">
+            <a:extLst>
+              <a:ext uri="{FF2B5EF4-FFF2-40B4-BE49-F238E27FC236}">
+                <a16:creationId xmlns:a16="http://schemas.microsoft.com/office/drawing/2014/main" id="{1FFDA2A6-88FE-82E3-F208-14397B7B991C}"/>
+              </a:ext>
+            </a:extLst>
+          </p:cNvPr>
+          <p:cNvPicPr>
+            <a:picLocks noChangeAspect="1"/>
+          </p:cNvPicPr>
+          <p:nvPr/>
+        </p:nvPicPr>
+        <p:blipFill>
+          <a:blip r:embed="rId3">
+            <a:extLst>
+              <a:ext uri="{28A0092B-C50C-407E-A947-70E740481C1C}">
+                <a14:useLocalDpi xmlns:a14="http://schemas.microsoft.com/office/drawing/2010/main" val="0"/>
+              </a:ext>
+            </a:extLst>
+          </a:blip>
+          <a:stretch>
+            <a:fillRect/>
+          </a:stretch>
+        </p:blipFill>
+        <p:spPr>
+          <a:xfrm>
+            <a:off x="6043841" y="5118100"/>
+            <a:ext cx="1690758" cy="1511292"/>
+          </a:xfrm>
+          <a:prstGeom prst="rect">
+            <a:avLst/>
+          </a:prstGeom>
+        </p:spPr>
+      </p:pic>
+      <p:pic>
+        <p:nvPicPr>
+          <p:cNvPr id="68" name="圖片 67">
+            <a:extLst>
+              <a:ext uri="{FF2B5EF4-FFF2-40B4-BE49-F238E27FC236}">
+                <a16:creationId xmlns:a16="http://schemas.microsoft.com/office/drawing/2014/main" id="{C7AC3D9B-62AE-472C-50A0-0E637D323778}"/>
+              </a:ext>
+            </a:extLst>
+          </p:cNvPr>
+          <p:cNvPicPr>
+            <a:picLocks noChangeAspect="1"/>
+          </p:cNvPicPr>
+          <p:nvPr/>
+        </p:nvPicPr>
+        <p:blipFill>
+          <a:blip r:embed="rId4"/>
+          <a:srcRect b="68468"/>
+          <a:stretch>
+            <a:fillRect/>
+          </a:stretch>
+        </p:blipFill>
+        <p:spPr>
+          <a:xfrm>
+            <a:off x="4347235" y="732552"/>
+            <a:ext cx="4515480" cy="1120426"/>
+          </a:xfrm>
+          <a:prstGeom prst="rect">
+            <a:avLst/>
+          </a:prstGeom>
+        </p:spPr>
+      </p:pic>
+      <p:pic>
+        <p:nvPicPr>
+          <p:cNvPr id="70" name="圖片 69">
+            <a:extLst>
+              <a:ext uri="{FF2B5EF4-FFF2-40B4-BE49-F238E27FC236}">
+                <a16:creationId xmlns:a16="http://schemas.microsoft.com/office/drawing/2014/main" id="{399808B6-9B4C-4B53-F7E9-E042E2ADA6A5}"/>
+              </a:ext>
+            </a:extLst>
+          </p:cNvPr>
+          <p:cNvPicPr>
+            <a:picLocks noChangeAspect="1"/>
+          </p:cNvPicPr>
+          <p:nvPr/>
+        </p:nvPicPr>
+        <p:blipFill>
+          <a:blip r:embed="rId4"/>
+          <a:srcRect t="83300"/>
+          <a:stretch>
+            <a:fillRect/>
+          </a:stretch>
+        </p:blipFill>
+        <p:spPr>
+          <a:xfrm>
+            <a:off x="4270003" y="4295325"/>
+            <a:ext cx="4515480" cy="593407"/>
+          </a:xfrm>
+          <a:prstGeom prst="rect">
+            <a:avLst/>
+          </a:prstGeom>
+        </p:spPr>
+      </p:pic>
+      <p:pic>
+        <p:nvPicPr>
+          <p:cNvPr id="72" name="圖片 71">
+            <a:extLst>
+              <a:ext uri="{FF2B5EF4-FFF2-40B4-BE49-F238E27FC236}">
+                <a16:creationId xmlns:a16="http://schemas.microsoft.com/office/drawing/2014/main" id="{9BA4935B-F3D7-E7EE-6530-C90B663E5DCF}"/>
+              </a:ext>
+            </a:extLst>
+          </p:cNvPr>
+          <p:cNvPicPr>
+            <a:picLocks noChangeAspect="1"/>
+          </p:cNvPicPr>
+          <p:nvPr/>
+        </p:nvPicPr>
+        <p:blipFill>
+          <a:blip r:embed="rId4"/>
+          <a:srcRect t="31532" b="16700"/>
+          <a:stretch>
+            <a:fillRect/>
+          </a:stretch>
+        </p:blipFill>
+        <p:spPr>
+          <a:xfrm>
+            <a:off x="4289053" y="1949037"/>
+            <a:ext cx="4515480" cy="1839488"/>
+          </a:xfrm>
+          <a:prstGeom prst="rect">
+            <a:avLst/>
+          </a:prstGeom>
+        </p:spPr>
+      </p:pic>
+      <p:grpSp>
+        <p:nvGrpSpPr>
+          <p:cNvPr id="73" name="群組 72">
+            <a:extLst>
+              <a:ext uri="{FF2B5EF4-FFF2-40B4-BE49-F238E27FC236}">
+                <a16:creationId xmlns:a16="http://schemas.microsoft.com/office/drawing/2014/main" id="{2380DEBC-AE21-9AF5-96BA-358CA6AEB633}"/>
+              </a:ext>
+            </a:extLst>
+          </p:cNvPr>
+          <p:cNvGrpSpPr/>
+          <p:nvPr/>
+        </p:nvGrpSpPr>
+        <p:grpSpPr>
+          <a:xfrm>
+            <a:off x="377129" y="5026968"/>
+            <a:ext cx="1879486" cy="1408848"/>
+            <a:chOff x="6662426" y="284834"/>
+            <a:chExt cx="1529547" cy="1213191"/>
+          </a:xfrm>
+        </p:grpSpPr>
+        <p:pic>
+          <p:nvPicPr>
+            <p:cNvPr id="74" name="圖片 73">
+              <a:extLst>
+                <a:ext uri="{FF2B5EF4-FFF2-40B4-BE49-F238E27FC236}">
+                  <a16:creationId xmlns:a16="http://schemas.microsoft.com/office/drawing/2014/main" id="{3B106A0E-6E0E-63F2-6244-6CC490DC0225}"/>
+                </a:ext>
+              </a:extLst>
+            </p:cNvPr>
+            <p:cNvPicPr>
+              <a:picLocks noChangeAspect="1"/>
+            </p:cNvPicPr>
+            <p:nvPr/>
+          </p:nvPicPr>
+          <p:blipFill>
+            <a:blip r:embed="rId5"/>
+            <a:srcRect b="10614"/>
+            <a:stretch>
+              <a:fillRect/>
+            </a:stretch>
+          </p:blipFill>
+          <p:spPr>
+            <a:xfrm>
+              <a:off x="6662426" y="284834"/>
+              <a:ext cx="1418307" cy="1213191"/>
+            </a:xfrm>
+            <a:prstGeom prst="rect">
+              <a:avLst/>
+            </a:prstGeom>
+          </p:spPr>
+        </p:pic>
+        <p:sp>
+          <p:nvSpPr>
+            <p:cNvPr id="75" name="流程圖: 接點 74">
+              <a:extLst>
+                <a:ext uri="{FF2B5EF4-FFF2-40B4-BE49-F238E27FC236}">
+                  <a16:creationId xmlns:a16="http://schemas.microsoft.com/office/drawing/2014/main" id="{BCAD4408-B390-1781-6F16-0839120A4547}"/>
+                </a:ext>
+              </a:extLst>
+            </p:cNvPr>
+            <p:cNvSpPr/>
+            <p:nvPr/>
+          </p:nvSpPr>
+          <p:spPr>
+            <a:xfrm>
+              <a:off x="7448452" y="922892"/>
+              <a:ext cx="200759" cy="188351"/>
+            </a:xfrm>
+            <a:prstGeom prst="flowChartConnector">
+              <a:avLst/>
+            </a:prstGeom>
+          </p:spPr>
+          <p:style>
+            <a:lnRef idx="2">
+              <a:schemeClr val="accent6">
+                <a:shade val="15000"/>
+              </a:schemeClr>
+            </a:lnRef>
+            <a:fillRef idx="1">
+              <a:schemeClr val="accent6"/>
+            </a:fillRef>
+            <a:effectRef idx="0">
+              <a:schemeClr val="accent6"/>
+            </a:effectRef>
+            <a:fontRef idx="minor">
+              <a:schemeClr val="lt1"/>
+            </a:fontRef>
+          </p:style>
+          <p:txBody>
+            <a:bodyPr rtlCol="0" anchor="ctr"/>
+            <a:lstStyle/>
+            <a:p>
+              <a:pPr algn="ctr"/>
+              <a:endParaRPr lang="zh-HK" altLang="en-US"/>
+            </a:p>
+          </p:txBody>
+        </p:sp>
+        <p:sp>
+          <p:nvSpPr>
+            <p:cNvPr id="76" name="圖說文字: 直線 75">
+              <a:extLst>
+                <a:ext uri="{FF2B5EF4-FFF2-40B4-BE49-F238E27FC236}">
+                  <a16:creationId xmlns:a16="http://schemas.microsoft.com/office/drawing/2014/main" id="{40AB535A-ED35-E9BB-5488-0F0F37330783}"/>
+                </a:ext>
+              </a:extLst>
+            </p:cNvPr>
+            <p:cNvSpPr/>
+            <p:nvPr/>
+          </p:nvSpPr>
+          <p:spPr>
+            <a:xfrm>
+              <a:off x="7826672" y="659978"/>
+              <a:ext cx="365301" cy="168002"/>
+            </a:xfrm>
+            <a:prstGeom prst="borderCallout1">
+              <a:avLst/>
+            </a:prstGeom>
+            <a:noFill/>
+            <a:ln w="3175"/>
+          </p:spPr>
+          <p:style>
+            <a:lnRef idx="2">
+              <a:schemeClr val="accent1">
+                <a:shade val="15000"/>
+              </a:schemeClr>
+            </a:lnRef>
+            <a:fillRef idx="1">
+              <a:schemeClr val="accent1"/>
+            </a:fillRef>
+            <a:effectRef idx="0">
+              <a:schemeClr val="accent1"/>
+            </a:effectRef>
+            <a:fontRef idx="minor">
+              <a:schemeClr val="lt1"/>
+            </a:fontRef>
+          </p:style>
+          <p:txBody>
+            <a:bodyPr rtlCol="0" anchor="ctr"/>
+            <a:lstStyle/>
+            <a:p>
+              <a:pPr algn="ctr"/>
+              <a:endParaRPr lang="zh-HK" altLang="en-US"/>
+            </a:p>
+          </p:txBody>
+        </p:sp>
+      </p:grpSp>
+      <p:grpSp>
+        <p:nvGrpSpPr>
+          <p:cNvPr id="77" name="群組 76">
+            <a:extLst>
+              <a:ext uri="{FF2B5EF4-FFF2-40B4-BE49-F238E27FC236}">
+                <a16:creationId xmlns:a16="http://schemas.microsoft.com/office/drawing/2014/main" id="{34D1637C-855D-86FE-70E6-EBD7CD23459E}"/>
+              </a:ext>
+            </a:extLst>
+          </p:cNvPr>
+          <p:cNvGrpSpPr/>
+          <p:nvPr/>
+        </p:nvGrpSpPr>
+        <p:grpSpPr>
+          <a:xfrm>
+            <a:off x="2697415" y="5118100"/>
+            <a:ext cx="1729769" cy="1285740"/>
+            <a:chOff x="6467731" y="2801152"/>
+            <a:chExt cx="1457069" cy="1013663"/>
+          </a:xfrm>
+        </p:grpSpPr>
+        <p:pic>
+          <p:nvPicPr>
+            <p:cNvPr id="78" name="圖片 77">
+              <a:extLst>
+                <a:ext uri="{FF2B5EF4-FFF2-40B4-BE49-F238E27FC236}">
+                  <a16:creationId xmlns:a16="http://schemas.microsoft.com/office/drawing/2014/main" id="{30B49643-5AF1-6CE4-BFCD-D019E47E79D6}"/>
+                </a:ext>
+              </a:extLst>
+            </p:cNvPr>
+            <p:cNvPicPr>
+              <a:picLocks noChangeAspect="1"/>
+            </p:cNvPicPr>
+            <p:nvPr/>
+          </p:nvPicPr>
+          <p:blipFill>
+            <a:blip r:embed="rId6">
+              <a:extLst>
+                <a:ext uri="{28A0092B-C50C-407E-A947-70E740481C1C}">
+                  <a14:useLocalDpi xmlns:a14="http://schemas.microsoft.com/office/drawing/2010/main" val="0"/>
+                </a:ext>
+              </a:extLst>
+            </a:blip>
+            <a:srcRect r="46056"/>
+            <a:stretch>
+              <a:fillRect/>
+            </a:stretch>
+          </p:blipFill>
+          <p:spPr>
+            <a:xfrm>
+              <a:off x="6467731" y="2801152"/>
+              <a:ext cx="999595" cy="1013663"/>
+            </a:xfrm>
+            <a:prstGeom prst="rect">
+              <a:avLst/>
+            </a:prstGeom>
+          </p:spPr>
+        </p:pic>
+        <p:sp>
+          <p:nvSpPr>
+            <p:cNvPr id="79" name="矩形 78">
+              <a:extLst>
+                <a:ext uri="{FF2B5EF4-FFF2-40B4-BE49-F238E27FC236}">
+                  <a16:creationId xmlns:a16="http://schemas.microsoft.com/office/drawing/2014/main" id="{1602C02A-8AEF-872E-1F9D-BE0A2DD445DE}"/>
+                </a:ext>
+              </a:extLst>
+            </p:cNvPr>
+            <p:cNvSpPr/>
+            <p:nvPr/>
+          </p:nvSpPr>
+          <p:spPr>
+            <a:xfrm>
+              <a:off x="7323844" y="3102420"/>
+              <a:ext cx="600956" cy="124154"/>
+            </a:xfrm>
+            <a:prstGeom prst="rect">
+              <a:avLst/>
+            </a:prstGeom>
+            <a:solidFill>
+              <a:schemeClr val="bg1"/>
+            </a:solidFill>
+            <a:ln w="6350">
+              <a:solidFill>
+                <a:schemeClr val="tx1"/>
+              </a:solidFill>
+            </a:ln>
+          </p:spPr>
+          <p:style>
+            <a:lnRef idx="2">
+              <a:schemeClr val="accent1">
+                <a:shade val="15000"/>
+              </a:schemeClr>
+            </a:lnRef>
+            <a:fillRef idx="1">
+              <a:schemeClr val="accent1"/>
+            </a:fillRef>
+            <a:effectRef idx="0">
+              <a:schemeClr val="accent1"/>
+            </a:effectRef>
+            <a:fontRef idx="minor">
+              <a:schemeClr val="lt1"/>
+            </a:fontRef>
+          </p:style>
+          <p:txBody>
+            <a:bodyPr rtlCol="0" anchor="ctr"/>
+            <a:lstStyle/>
+            <a:p>
+              <a:pPr algn="ctr"/>
+              <a:r>
+                <a:rPr lang="en-US" altLang="zh-HK" sz="300" dirty="0">
+                  <a:ln w="0"/>
+                  <a:solidFill>
+                    <a:schemeClr val="tx1"/>
+                  </a:solidFill>
+                </a:rPr>
+                <a:t>School name+ type</a:t>
+              </a:r>
+              <a:br>
+                <a:rPr lang="en-US" altLang="zh-HK" sz="300" dirty="0">
+                  <a:ln w="0"/>
+                  <a:solidFill>
+                    <a:schemeClr val="tx1"/>
+                  </a:solidFill>
+                </a:rPr>
+              </a:br>
+              <a:r>
+                <a:rPr lang="zh-HK" altLang="zh-HK" sz="300" b="1" dirty="0">
+                  <a:solidFill>
+                    <a:schemeClr val="tx1"/>
+                  </a:solidFill>
+                </a:rPr>
+                <a:t>See its three-year trend</a:t>
+              </a:r>
+              <a:endParaRPr lang="zh-HK" altLang="en-US" sz="300" dirty="0">
+                <a:solidFill>
+                  <a:schemeClr val="tx1"/>
+                </a:solidFill>
+              </a:endParaRPr>
+            </a:p>
+          </p:txBody>
+        </p:sp>
+        <p:pic>
+          <p:nvPicPr>
+            <p:cNvPr id="80" name="圖片 79">
+              <a:extLst>
+                <a:ext uri="{FF2B5EF4-FFF2-40B4-BE49-F238E27FC236}">
+                  <a16:creationId xmlns:a16="http://schemas.microsoft.com/office/drawing/2014/main" id="{8D3B91CE-3F32-56A3-90EB-4050D0F1121D}"/>
+                </a:ext>
+              </a:extLst>
+            </p:cNvPr>
+            <p:cNvPicPr>
+              <a:picLocks noChangeAspect="1"/>
+            </p:cNvPicPr>
+            <p:nvPr/>
+          </p:nvPicPr>
+          <p:blipFill>
+            <a:blip r:embed="rId6">
+              <a:extLst>
+                <a:ext uri="{28A0092B-C50C-407E-A947-70E740481C1C}">
+                  <a14:useLocalDpi xmlns:a14="http://schemas.microsoft.com/office/drawing/2010/main" val="0"/>
+                </a:ext>
+              </a:extLst>
+            </a:blip>
+            <a:srcRect l="58027" t="24395" r="5900" b="21499"/>
+            <a:stretch>
+              <a:fillRect/>
+            </a:stretch>
+          </p:blipFill>
+          <p:spPr>
+            <a:xfrm>
+              <a:off x="7328885" y="3243032"/>
+              <a:ext cx="509749" cy="418248"/>
+            </a:xfrm>
+            <a:prstGeom prst="rect">
+              <a:avLst/>
+            </a:prstGeom>
+          </p:spPr>
+        </p:pic>
+        <p:sp>
+          <p:nvSpPr>
+            <p:cNvPr id="81" name="矩形 80">
+              <a:extLst>
+                <a:ext uri="{FF2B5EF4-FFF2-40B4-BE49-F238E27FC236}">
+                  <a16:creationId xmlns:a16="http://schemas.microsoft.com/office/drawing/2014/main" id="{464901CD-6C19-356C-B8C0-8FB9B3E19E75}"/>
+                </a:ext>
+              </a:extLst>
+            </p:cNvPr>
+            <p:cNvSpPr/>
+            <p:nvPr/>
+          </p:nvSpPr>
+          <p:spPr>
+            <a:xfrm>
+              <a:off x="7385303" y="3164497"/>
+              <a:ext cx="37785" cy="45719"/>
+            </a:xfrm>
+            <a:prstGeom prst="rect">
+              <a:avLst/>
+            </a:prstGeom>
+            <a:ln w="3175"/>
+          </p:spPr>
+          <p:style>
+            <a:lnRef idx="2">
+              <a:schemeClr val="accent1">
+                <a:shade val="15000"/>
+              </a:schemeClr>
+            </a:lnRef>
+            <a:fillRef idx="1">
+              <a:schemeClr val="accent1"/>
+            </a:fillRef>
+            <a:effectRef idx="0">
+              <a:schemeClr val="accent1"/>
+            </a:effectRef>
+            <a:fontRef idx="minor">
+              <a:schemeClr val="lt1"/>
+            </a:fontRef>
+          </p:style>
+          <p:txBody>
+            <a:bodyPr rtlCol="0" anchor="ctr"/>
+            <a:lstStyle/>
+            <a:p>
+              <a:pPr algn="ctr"/>
+              <a:endParaRPr lang="zh-HK" altLang="en-US">
+                <a:ln w="0"/>
+                <a:solidFill>
+                  <a:schemeClr val="tx1"/>
+                </a:solidFill>
+                <a:effectLst>
+                  <a:outerShdw blurRad="38100" dist="19050" dir="2700000" algn="tl" rotWithShape="0">
+                    <a:schemeClr val="dk1">
+                      <a:alpha val="40000"/>
+                    </a:schemeClr>
+                  </a:outerShdw>
+                </a:effectLst>
+              </a:endParaRPr>
+            </a:p>
+          </p:txBody>
+        </p:sp>
+        <p:sp>
+          <p:nvSpPr>
+            <p:cNvPr id="82" name="手繪多邊形: 圖案 81">
+              <a:extLst>
+                <a:ext uri="{FF2B5EF4-FFF2-40B4-BE49-F238E27FC236}">
+                  <a16:creationId xmlns:a16="http://schemas.microsoft.com/office/drawing/2014/main" id="{CBA8B007-7193-0417-C642-FB4EA845CB74}"/>
+                </a:ext>
+              </a:extLst>
+            </p:cNvPr>
+            <p:cNvSpPr/>
+            <p:nvPr/>
+          </p:nvSpPr>
+          <p:spPr>
+            <a:xfrm>
+              <a:off x="7393781" y="3157538"/>
+              <a:ext cx="47625" cy="43499"/>
+            </a:xfrm>
+            <a:custGeom>
+              <a:avLst/>
+              <a:gdLst>
+                <a:gd name="csX0" fmla="*/ 0 w 47625"/>
+                <a:gd name="csY0" fmla="*/ 28575 h 43499"/>
+                <a:gd name="csX1" fmla="*/ 35719 w 47625"/>
+                <a:gd name="csY1" fmla="*/ 14287 h 43499"/>
+                <a:gd name="csX2" fmla="*/ 47625 w 47625"/>
+                <a:gd name="csY2" fmla="*/ 0 h 43499"/>
+              </a:gdLst>
+              <a:ahLst/>
+              <a:cxnLst>
+                <a:cxn ang="0">
+                  <a:pos x="csX0" y="csY0"/>
+                </a:cxn>
+                <a:cxn ang="0">
+                  <a:pos x="csX1" y="csY1"/>
+                </a:cxn>
+                <a:cxn ang="0">
+                  <a:pos x="csX2" y="csY2"/>
+                </a:cxn>
+              </a:cxnLst>
+              <a:rect l="l" t="t" r="r" b="b"/>
+              <a:pathLst>
+                <a:path w="47625" h="43499">
+                  <a:moveTo>
+                    <a:pt x="0" y="28575"/>
+                  </a:moveTo>
+                  <a:cubicBezTo>
+                    <a:pt x="4961" y="53372"/>
+                    <a:pt x="-125" y="46358"/>
+                    <a:pt x="35719" y="14287"/>
+                  </a:cubicBezTo>
+                  <a:cubicBezTo>
+                    <a:pt x="40339" y="10153"/>
+                    <a:pt x="47625" y="0"/>
+                    <a:pt x="47625" y="0"/>
+                  </a:cubicBezTo>
+                </a:path>
+              </a:pathLst>
+            </a:custGeom>
+            <a:ln w="3175"/>
+          </p:spPr>
+          <p:style>
+            <a:lnRef idx="1">
+              <a:schemeClr val="dk1"/>
+            </a:lnRef>
+            <a:fillRef idx="0">
+              <a:schemeClr val="dk1"/>
+            </a:fillRef>
+            <a:effectRef idx="0">
+              <a:schemeClr val="dk1"/>
+            </a:effectRef>
+            <a:fontRef idx="minor">
+              <a:schemeClr val="tx1"/>
+            </a:fontRef>
+          </p:style>
+          <p:txBody>
+            <a:bodyPr rtlCol="0" anchor="ctr"/>
+            <a:lstStyle/>
+            <a:p>
+              <a:pPr algn="ctr"/>
+              <a:endParaRPr lang="zh-HK" altLang="en-US"/>
+            </a:p>
+          </p:txBody>
+        </p:sp>
+      </p:grpSp>
+      <p:pic>
+        <p:nvPicPr>
+          <p:cNvPr id="84" name="圖片 83">
+            <a:extLst>
+              <a:ext uri="{FF2B5EF4-FFF2-40B4-BE49-F238E27FC236}">
+                <a16:creationId xmlns:a16="http://schemas.microsoft.com/office/drawing/2014/main" id="{5FC74858-241C-2748-B964-599095A80C05}"/>
+              </a:ext>
+            </a:extLst>
+          </p:cNvPr>
+          <p:cNvPicPr>
+            <a:picLocks noChangeAspect="1"/>
+          </p:cNvPicPr>
+          <p:nvPr/>
+        </p:nvPicPr>
+        <p:blipFill>
+          <a:blip r:embed="rId7"/>
+          <a:stretch>
+            <a:fillRect/>
+          </a:stretch>
+        </p:blipFill>
+        <p:spPr>
+          <a:xfrm>
+            <a:off x="4500146" y="5256112"/>
+            <a:ext cx="1444109" cy="1123196"/>
+          </a:xfrm>
+          <a:prstGeom prst="rect">
+            <a:avLst/>
+          </a:prstGeom>
+        </p:spPr>
+      </p:pic>
     </p:spTree>
   </p:cSld>
   <p:clrMapOvr>

</xml_diff>